<commit_message>
update: Raiffeisen Entscheidungsvorlage v2 — cleaner layout
Co-Authored-By: Claude Opus 4.6 (1M context) <noreply@anthropic.com>
</commit_message>
<xml_diff>
--- a/Raiffeisen-Entscheidungsvorlage.pptx
+++ b/Raiffeisen-Entscheidungsvorlage.pptx
@@ -3098,19 +3098,17 @@
       <p:grpSpPr/>
       <p:sp>
         <p:nvSpPr>
-          <p:cNvPr id="2" name="Rounded Rectangle 1"/>
+          <p:cNvPr id="2" name="Rectangle 1"/>
           <p:cNvSpPr/>
           <p:nvPr/>
         </p:nvSpPr>
         <p:spPr>
           <a:xfrm>
             <a:off x="0" y="0"/>
-            <a:ext cx="14630400" cy="822960"/>
-          </a:xfrm>
-          <a:prstGeom prst="roundRect">
-            <a:avLst>
-              <a:gd name="adj" fmla="val 3000"/>
-            </a:avLst>
+            <a:ext cx="14630400" cy="640080"/>
+          </a:xfrm>
+          <a:prstGeom prst="rect">
+            <a:avLst/>
           </a:prstGeom>
           <a:solidFill>
             <a:srgbClr val="003366"/>
@@ -3149,8 +3147,8 @@
         </p:nvSpPr>
         <p:spPr>
           <a:xfrm>
-            <a:off x="731520" y="137160"/>
-            <a:ext cx="9144000" cy="274320"/>
+            <a:off x="731520" y="164592"/>
+            <a:ext cx="9144000" cy="320040"/>
           </a:xfrm>
           <a:prstGeom prst="rect">
             <a:avLst/>
@@ -3167,7 +3165,7 @@
               <a:spcAft>
                 <a:spcPts val="0"/>
               </a:spcAft>
-              <a:defRPr sz="1100" b="1">
+              <a:defRPr sz="1600" b="1">
                 <a:solidFill>
                   <a:srgbClr val="FFFFFF"/>
                 </a:solidFill>
@@ -3175,7 +3173,7 @@
               </a:defRPr>
             </a:pPr>
             <a:r>
-              <a:t>ENTSCHEIDUNGSVORLAGE</a:t>
+              <a:t>AI Test &amp; Learn im Vertrieb — Pilotvorschlag</a:t>
             </a:r>
           </a:p>
         </p:txBody>
@@ -3188,8 +3186,8 @@
         </p:nvSpPr>
         <p:spPr>
           <a:xfrm>
-            <a:off x="731520" y="411480"/>
-            <a:ext cx="9144000" cy="274320"/>
+            <a:off x="10058400" y="164592"/>
+            <a:ext cx="3840480" cy="320040"/>
           </a:xfrm>
           <a:prstGeom prst="rect">
             <a:avLst/>
@@ -3202,19 +3200,19 @@
           </a:bodyPr>
           <a:lstStyle/>
           <a:p>
-            <a:pPr algn="l">
+            <a:pPr algn="r">
               <a:spcAft>
                 <a:spcPts val="0"/>
               </a:spcAft>
-              <a:defRPr sz="1600" b="1">
-                <a:solidFill>
-                  <a:srgbClr val="FFFFFF"/>
-                </a:solidFill>
-                <a:latin typeface="Arial"/>
-              </a:defRPr>
-            </a:pPr>
-            <a:r>
-              <a:t>AI Test &amp; Learn im Vertrieb — Pilotvorschlag</a:t>
+              <a:defRPr sz="900" b="0">
+                <a:solidFill>
+                  <a:srgbClr val="88AACC"/>
+                </a:solidFill>
+                <a:latin typeface="Arial"/>
+              </a:defRPr>
+            </a:pPr>
+            <a:r>
+              <a:t>Vertraulich · März 2026</a:t>
             </a:r>
           </a:p>
         </p:txBody>
@@ -3227,8 +3225,8 @@
         </p:nvSpPr>
         <p:spPr>
           <a:xfrm>
-            <a:off x="10058400" y="137160"/>
-            <a:ext cx="3840480" cy="274320"/>
+            <a:off x="731520" y="777240"/>
+            <a:ext cx="2468880" cy="182880"/>
           </a:xfrm>
           <a:prstGeom prst="rect">
             <a:avLst/>
@@ -3241,19 +3239,19 @@
           </a:bodyPr>
           <a:lstStyle/>
           <a:p>
-            <a:pPr algn="r">
+            <a:pPr algn="l">
               <a:spcAft>
                 <a:spcPts val="0"/>
               </a:spcAft>
-              <a:defRPr sz="900" b="0">
-                <a:solidFill>
-                  <a:srgbClr val="88AACC"/>
-                </a:solidFill>
-                <a:latin typeface="Arial"/>
-              </a:defRPr>
-            </a:pPr>
-            <a:r>
-              <a:t>Vertraulich · März 2026</a:t>
+              <a:defRPr sz="800" b="1">
+                <a:solidFill>
+                  <a:srgbClr val="777777"/>
+                </a:solidFill>
+                <a:latin typeface="Arial"/>
+              </a:defRPr>
+            </a:pPr>
+            <a:r>
+              <a:t>Thema</a:t>
             </a:r>
           </a:p>
         </p:txBody>
@@ -3266,8 +3264,8 @@
         </p:nvSpPr>
         <p:spPr>
           <a:xfrm>
-            <a:off x="10058400" y="411480"/>
-            <a:ext cx="3840480" cy="274320"/>
+            <a:off x="731520" y="960120"/>
+            <a:ext cx="2468880" cy="182880"/>
           </a:xfrm>
           <a:prstGeom prst="rect">
             <a:avLst/>
@@ -3280,32 +3278,344 @@
           </a:bodyPr>
           <a:lstStyle/>
           <a:p>
-            <a:pPr algn="r">
+            <a:pPr algn="l">
               <a:spcAft>
                 <a:spcPts val="0"/>
               </a:spcAft>
-              <a:defRPr sz="1100" b="0">
-                <a:solidFill>
-                  <a:srgbClr val="FFFFFF"/>
-                </a:solidFill>
-                <a:latin typeface="Arial"/>
-              </a:defRPr>
-            </a:pPr>
-            <a:r>
-              <a:t>Ivo Schneider, Leiter Vertrieb</a:t>
-            </a:r>
-          </a:p>
-        </p:txBody>
-      </p:sp>
-      <p:sp>
-        <p:nvSpPr>
-          <p:cNvPr id="7" name="Rectangle 6"/>
+              <a:defRPr sz="1000" b="1">
+                <a:solidFill>
+                  <a:srgbClr val="1A1A1A"/>
+                </a:solidFill>
+                <a:latin typeface="Arial"/>
+              </a:defRPr>
+            </a:pPr>
+            <a:r>
+              <a:t>AI-Pilotprojekt Vertrieb</a:t>
+            </a:r>
+          </a:p>
+        </p:txBody>
+      </p:sp>
+      <p:sp>
+        <p:nvSpPr>
+          <p:cNvPr id="7" name="TextBox 6"/>
+          <p:cNvSpPr txBox="1"/>
+          <p:nvPr/>
+        </p:nvSpPr>
+        <p:spPr>
+          <a:xfrm>
+            <a:off x="3429000" y="777240"/>
+            <a:ext cx="2468880" cy="182880"/>
+          </a:xfrm>
+          <a:prstGeom prst="rect">
+            <a:avLst/>
+          </a:prstGeom>
+          <a:noFill/>
+        </p:spPr>
+        <p:txBody>
+          <a:bodyPr wrap="square">
+            <a:spAutoFit/>
+          </a:bodyPr>
+          <a:lstStyle/>
+          <a:p>
+            <a:pPr algn="l">
+              <a:spcAft>
+                <a:spcPts val="0"/>
+              </a:spcAft>
+              <a:defRPr sz="800" b="1">
+                <a:solidFill>
+                  <a:srgbClr val="777777"/>
+                </a:solidFill>
+                <a:latin typeface="Arial"/>
+              </a:defRPr>
+            </a:pPr>
+            <a:r>
+              <a:t>Partner</a:t>
+            </a:r>
+          </a:p>
+        </p:txBody>
+      </p:sp>
+      <p:sp>
+        <p:nvSpPr>
+          <p:cNvPr id="8" name="TextBox 7"/>
+          <p:cNvSpPr txBox="1"/>
+          <p:nvPr/>
+        </p:nvSpPr>
+        <p:spPr>
+          <a:xfrm>
+            <a:off x="3429000" y="960120"/>
+            <a:ext cx="2468880" cy="182880"/>
+          </a:xfrm>
+          <a:prstGeom prst="rect">
+            <a:avLst/>
+          </a:prstGeom>
+          <a:noFill/>
+        </p:spPr>
+        <p:txBody>
+          <a:bodyPr wrap="square">
+            <a:spAutoFit/>
+          </a:bodyPr>
+          <a:lstStyle/>
+          <a:p>
+            <a:pPr algn="l">
+              <a:spcAft>
+                <a:spcPts val="0"/>
+              </a:spcAft>
+              <a:defRPr sz="1000" b="1">
+                <a:solidFill>
+                  <a:srgbClr val="1A1A1A"/>
+                </a:solidFill>
+                <a:latin typeface="Arial"/>
+              </a:defRPr>
+            </a:pPr>
+            <a:r>
+              <a:t>Salesteq, Zug (CH)</a:t>
+            </a:r>
+          </a:p>
+        </p:txBody>
+      </p:sp>
+      <p:sp>
+        <p:nvSpPr>
+          <p:cNvPr id="9" name="TextBox 8"/>
+          <p:cNvSpPr txBox="1"/>
+          <p:nvPr/>
+        </p:nvSpPr>
+        <p:spPr>
+          <a:xfrm>
+            <a:off x="6126480" y="777240"/>
+            <a:ext cx="2468880" cy="182880"/>
+          </a:xfrm>
+          <a:prstGeom prst="rect">
+            <a:avLst/>
+          </a:prstGeom>
+          <a:noFill/>
+        </p:spPr>
+        <p:txBody>
+          <a:bodyPr wrap="square">
+            <a:spAutoFit/>
+          </a:bodyPr>
+          <a:lstStyle/>
+          <a:p>
+            <a:pPr algn="l">
+              <a:spcAft>
+                <a:spcPts val="0"/>
+              </a:spcAft>
+              <a:defRPr sz="800" b="1">
+                <a:solidFill>
+                  <a:srgbClr val="777777"/>
+                </a:solidFill>
+                <a:latin typeface="Arial"/>
+              </a:defRPr>
+            </a:pPr>
+            <a:r>
+              <a:t>Umfang</a:t>
+            </a:r>
+          </a:p>
+        </p:txBody>
+      </p:sp>
+      <p:sp>
+        <p:nvSpPr>
+          <p:cNvPr id="10" name="TextBox 9"/>
+          <p:cNvSpPr txBox="1"/>
+          <p:nvPr/>
+        </p:nvSpPr>
+        <p:spPr>
+          <a:xfrm>
+            <a:off x="6126480" y="960120"/>
+            <a:ext cx="2468880" cy="182880"/>
+          </a:xfrm>
+          <a:prstGeom prst="rect">
+            <a:avLst/>
+          </a:prstGeom>
+          <a:noFill/>
+        </p:spPr>
+        <p:txBody>
+          <a:bodyPr wrap="square">
+            <a:spAutoFit/>
+          </a:bodyPr>
+          <a:lstStyle/>
+          <a:p>
+            <a:pPr algn="l">
+              <a:spcAft>
+                <a:spcPts val="0"/>
+              </a:spcAft>
+              <a:defRPr sz="1000" b="1">
+                <a:solidFill>
+                  <a:srgbClr val="1A1A1A"/>
+                </a:solidFill>
+                <a:latin typeface="Arial"/>
+              </a:defRPr>
+            </a:pPr>
+            <a:r>
+              <a:t>12 Wochen, 1 Raiffeisenbank</a:t>
+            </a:r>
+          </a:p>
+        </p:txBody>
+      </p:sp>
+      <p:sp>
+        <p:nvSpPr>
+          <p:cNvPr id="11" name="TextBox 10"/>
+          <p:cNvSpPr txBox="1"/>
+          <p:nvPr/>
+        </p:nvSpPr>
+        <p:spPr>
+          <a:xfrm>
+            <a:off x="8823960" y="777240"/>
+            <a:ext cx="2468880" cy="182880"/>
+          </a:xfrm>
+          <a:prstGeom prst="rect">
+            <a:avLst/>
+          </a:prstGeom>
+          <a:noFill/>
+        </p:spPr>
+        <p:txBody>
+          <a:bodyPr wrap="square">
+            <a:spAutoFit/>
+          </a:bodyPr>
+          <a:lstStyle/>
+          <a:p>
+            <a:pPr algn="l">
+              <a:spcAft>
+                <a:spcPts val="0"/>
+              </a:spcAft>
+              <a:defRPr sz="800" b="1">
+                <a:solidFill>
+                  <a:srgbClr val="777777"/>
+                </a:solidFill>
+                <a:latin typeface="Arial"/>
+              </a:defRPr>
+            </a:pPr>
+            <a:r>
+              <a:t>IT-Bedarf</a:t>
+            </a:r>
+          </a:p>
+        </p:txBody>
+      </p:sp>
+      <p:sp>
+        <p:nvSpPr>
+          <p:cNvPr id="12" name="TextBox 11"/>
+          <p:cNvSpPr txBox="1"/>
+          <p:nvPr/>
+        </p:nvSpPr>
+        <p:spPr>
+          <a:xfrm>
+            <a:off x="8823960" y="960120"/>
+            <a:ext cx="2468880" cy="182880"/>
+          </a:xfrm>
+          <a:prstGeom prst="rect">
+            <a:avLst/>
+          </a:prstGeom>
+          <a:noFill/>
+        </p:spPr>
+        <p:txBody>
+          <a:bodyPr wrap="square">
+            <a:spAutoFit/>
+          </a:bodyPr>
+          <a:lstStyle/>
+          <a:p>
+            <a:pPr algn="l">
+              <a:spcAft>
+                <a:spcPts val="0"/>
+              </a:spcAft>
+              <a:defRPr sz="1000" b="1">
+                <a:solidFill>
+                  <a:srgbClr val="1A1A1A"/>
+                </a:solidFill>
+                <a:latin typeface="Arial"/>
+              </a:defRPr>
+            </a:pPr>
+            <a:r>
+              <a:t>Keiner</a:t>
+            </a:r>
+          </a:p>
+        </p:txBody>
+      </p:sp>
+      <p:sp>
+        <p:nvSpPr>
+          <p:cNvPr id="13" name="TextBox 12"/>
+          <p:cNvSpPr txBox="1"/>
+          <p:nvPr/>
+        </p:nvSpPr>
+        <p:spPr>
+          <a:xfrm>
+            <a:off x="11521440" y="777240"/>
+            <a:ext cx="2468880" cy="182880"/>
+          </a:xfrm>
+          <a:prstGeom prst="rect">
+            <a:avLst/>
+          </a:prstGeom>
+          <a:noFill/>
+        </p:spPr>
+        <p:txBody>
+          <a:bodyPr wrap="square">
+            <a:spAutoFit/>
+          </a:bodyPr>
+          <a:lstStyle/>
+          <a:p>
+            <a:pPr algn="l">
+              <a:spcAft>
+                <a:spcPts val="0"/>
+              </a:spcAft>
+              <a:defRPr sz="800" b="1">
+                <a:solidFill>
+                  <a:srgbClr val="777777"/>
+                </a:solidFill>
+                <a:latin typeface="Arial"/>
+              </a:defRPr>
+            </a:pPr>
+            <a:r>
+              <a:t>Budget</a:t>
+            </a:r>
+          </a:p>
+        </p:txBody>
+      </p:sp>
+      <p:sp>
+        <p:nvSpPr>
+          <p:cNvPr id="14" name="TextBox 13"/>
+          <p:cNvSpPr txBox="1"/>
+          <p:nvPr/>
+        </p:nvSpPr>
+        <p:spPr>
+          <a:xfrm>
+            <a:off x="11521440" y="960120"/>
+            <a:ext cx="2468880" cy="182880"/>
+          </a:xfrm>
+          <a:prstGeom prst="rect">
+            <a:avLst/>
+          </a:prstGeom>
+          <a:noFill/>
+        </p:spPr>
+        <p:txBody>
+          <a:bodyPr wrap="square">
+            <a:spAutoFit/>
+          </a:bodyPr>
+          <a:lstStyle/>
+          <a:p>
+            <a:pPr algn="l">
+              <a:spcAft>
+                <a:spcPts val="0"/>
+              </a:spcAft>
+              <a:defRPr sz="1000" b="1">
+                <a:solidFill>
+                  <a:srgbClr val="1A1A1A"/>
+                </a:solidFill>
+                <a:latin typeface="Arial"/>
+              </a:defRPr>
+            </a:pPr>
+            <a:r>
+              <a:t>Keines</a:t>
+            </a:r>
+          </a:p>
+        </p:txBody>
+      </p:sp>
+      <p:sp>
+        <p:nvSpPr>
+          <p:cNvPr id="15" name="Rectangle 14"/>
           <p:cNvSpPr/>
           <p:nvPr/>
         </p:nvSpPr>
         <p:spPr>
           <a:xfrm>
-            <a:off x="731520" y="1005840"/>
+            <a:off x="731520" y="1234440"/>
             <a:ext cx="13167360" cy="12700"/>
           </a:xfrm>
           <a:prstGeom prst="rect">
@@ -3342,14 +3652,14 @@
       </p:sp>
       <p:sp>
         <p:nvSpPr>
-          <p:cNvPr id="8" name="TextBox 7"/>
+          <p:cNvPr id="16" name="TextBox 15"/>
           <p:cNvSpPr txBox="1"/>
           <p:nvPr/>
         </p:nvSpPr>
         <p:spPr>
           <a:xfrm>
-            <a:off x="731520" y="1097280"/>
-            <a:ext cx="2468880" cy="182880"/>
+            <a:off x="731520" y="1417320"/>
+            <a:ext cx="3657600" cy="182880"/>
           </a:xfrm>
           <a:prstGeom prst="rect">
             <a:avLst/>
@@ -3366,29 +3676,29 @@
               <a:spcAft>
                 <a:spcPts val="0"/>
               </a:spcAft>
-              <a:defRPr sz="800" b="1">
-                <a:solidFill>
-                  <a:srgbClr val="999999"/>
-                </a:solidFill>
-                <a:latin typeface="Arial"/>
-              </a:defRPr>
-            </a:pPr>
-            <a:r>
-              <a:t>Thema</a:t>
-            </a:r>
-          </a:p>
-        </p:txBody>
-      </p:sp>
-      <p:sp>
-        <p:nvSpPr>
-          <p:cNvPr id="9" name="TextBox 8"/>
+              <a:defRPr sz="900" b="1">
+                <a:solidFill>
+                  <a:srgbClr val="003366"/>
+                </a:solidFill>
+                <a:latin typeface="Arial"/>
+              </a:defRPr>
+            </a:pPr>
+            <a:r>
+              <a:t>AUSGANGSLAGE</a:t>
+            </a:r>
+          </a:p>
+        </p:txBody>
+      </p:sp>
+      <p:sp>
+        <p:nvSpPr>
+          <p:cNvPr id="17" name="TextBox 16"/>
           <p:cNvSpPr txBox="1"/>
           <p:nvPr/>
         </p:nvSpPr>
         <p:spPr>
           <a:xfrm>
-            <a:off x="731520" y="1280160"/>
-            <a:ext cx="2468880" cy="182880"/>
+            <a:off x="731520" y="1691640"/>
+            <a:ext cx="7772400" cy="1097280"/>
           </a:xfrm>
           <a:prstGeom prst="rect">
             <a:avLst/>
@@ -3402,330 +3712,78 @@
           <a:lstStyle/>
           <a:p>
             <a:pPr algn="l">
-              <a:spcAft>
-                <a:spcPts val="0"/>
-              </a:spcAft>
-              <a:defRPr sz="1000" b="1">
-                <a:solidFill>
-                  <a:srgbClr val="1A1A1A"/>
-                </a:solidFill>
-                <a:latin typeface="Arial"/>
-              </a:defRPr>
-            </a:pPr>
-            <a:r>
-              <a:t>AI-Pilotprojekt im Vertrieb</a:t>
-            </a:r>
-          </a:p>
-        </p:txBody>
-      </p:sp>
-      <p:sp>
-        <p:nvSpPr>
-          <p:cNvPr id="10" name="TextBox 9"/>
-          <p:cNvSpPr txBox="1"/>
-          <p:nvPr/>
-        </p:nvSpPr>
-        <p:spPr>
-          <a:xfrm>
-            <a:off x="3383280" y="1097280"/>
-            <a:ext cx="2468880" cy="182880"/>
-          </a:xfrm>
-          <a:prstGeom prst="rect">
-            <a:avLst/>
-          </a:prstGeom>
-          <a:noFill/>
-        </p:spPr>
-        <p:txBody>
-          <a:bodyPr wrap="square">
-            <a:spAutoFit/>
-          </a:bodyPr>
-          <a:lstStyle/>
-          <a:p>
-            <a:pPr algn="l">
-              <a:spcAft>
-                <a:spcPts val="0"/>
-              </a:spcAft>
-              <a:defRPr sz="800" b="1">
-                <a:solidFill>
-                  <a:srgbClr val="999999"/>
-                </a:solidFill>
-                <a:latin typeface="Arial"/>
-              </a:defRPr>
-            </a:pPr>
-            <a:r>
-              <a:t>Partner</a:t>
-            </a:r>
-          </a:p>
-        </p:txBody>
-      </p:sp>
-      <p:sp>
-        <p:nvSpPr>
-          <p:cNvPr id="11" name="TextBox 10"/>
-          <p:cNvSpPr txBox="1"/>
-          <p:nvPr/>
-        </p:nvSpPr>
-        <p:spPr>
-          <a:xfrm>
-            <a:off x="3383280" y="1280160"/>
-            <a:ext cx="2468880" cy="182880"/>
-          </a:xfrm>
-          <a:prstGeom prst="rect">
-            <a:avLst/>
-          </a:prstGeom>
-          <a:noFill/>
-        </p:spPr>
-        <p:txBody>
-          <a:bodyPr wrap="square">
-            <a:spAutoFit/>
-          </a:bodyPr>
-          <a:lstStyle/>
-          <a:p>
-            <a:pPr algn="l">
-              <a:spcAft>
-                <a:spcPts val="0"/>
-              </a:spcAft>
-              <a:defRPr sz="1000" b="1">
-                <a:solidFill>
-                  <a:srgbClr val="1A1A1A"/>
-                </a:solidFill>
-                <a:latin typeface="Arial"/>
-              </a:defRPr>
-            </a:pPr>
-            <a:r>
-              <a:t>Salesteq (Zug, Schweiz)</a:t>
-            </a:r>
-          </a:p>
-        </p:txBody>
-      </p:sp>
-      <p:sp>
-        <p:nvSpPr>
-          <p:cNvPr id="12" name="TextBox 11"/>
-          <p:cNvSpPr txBox="1"/>
-          <p:nvPr/>
-        </p:nvSpPr>
-        <p:spPr>
-          <a:xfrm>
-            <a:off x="6035040" y="1097280"/>
-            <a:ext cx="2468880" cy="182880"/>
-          </a:xfrm>
-          <a:prstGeom prst="rect">
-            <a:avLst/>
-          </a:prstGeom>
-          <a:noFill/>
-        </p:spPr>
-        <p:txBody>
-          <a:bodyPr wrap="square">
-            <a:spAutoFit/>
-          </a:bodyPr>
-          <a:lstStyle/>
-          <a:p>
-            <a:pPr algn="l">
-              <a:spcAft>
-                <a:spcPts val="0"/>
-              </a:spcAft>
-              <a:defRPr sz="800" b="1">
-                <a:solidFill>
-                  <a:srgbClr val="999999"/>
-                </a:solidFill>
-                <a:latin typeface="Arial"/>
-              </a:defRPr>
-            </a:pPr>
-            <a:r>
-              <a:t>Umfang</a:t>
-            </a:r>
-          </a:p>
-        </p:txBody>
-      </p:sp>
-      <p:sp>
-        <p:nvSpPr>
-          <p:cNvPr id="13" name="TextBox 12"/>
-          <p:cNvSpPr txBox="1"/>
-          <p:nvPr/>
-        </p:nvSpPr>
-        <p:spPr>
-          <a:xfrm>
-            <a:off x="6035040" y="1280160"/>
-            <a:ext cx="2468880" cy="182880"/>
-          </a:xfrm>
-          <a:prstGeom prst="rect">
-            <a:avLst/>
-          </a:prstGeom>
-          <a:noFill/>
-        </p:spPr>
-        <p:txBody>
-          <a:bodyPr wrap="square">
-            <a:spAutoFit/>
-          </a:bodyPr>
-          <a:lstStyle/>
-          <a:p>
-            <a:pPr algn="l">
-              <a:spcAft>
-                <a:spcPts val="0"/>
-              </a:spcAft>
-              <a:defRPr sz="1000" b="1">
-                <a:solidFill>
-                  <a:srgbClr val="1A1A1A"/>
-                </a:solidFill>
-                <a:latin typeface="Arial"/>
-              </a:defRPr>
-            </a:pPr>
-            <a:r>
-              <a:t>12 Wochen, 1 Raiffeisenbank</a:t>
-            </a:r>
-          </a:p>
-        </p:txBody>
-      </p:sp>
-      <p:sp>
-        <p:nvSpPr>
-          <p:cNvPr id="14" name="TextBox 13"/>
-          <p:cNvSpPr txBox="1"/>
-          <p:nvPr/>
-        </p:nvSpPr>
-        <p:spPr>
-          <a:xfrm>
-            <a:off x="8686800" y="1097280"/>
-            <a:ext cx="2468880" cy="182880"/>
-          </a:xfrm>
-          <a:prstGeom prst="rect">
-            <a:avLst/>
-          </a:prstGeom>
-          <a:noFill/>
-        </p:spPr>
-        <p:txBody>
-          <a:bodyPr wrap="square">
-            <a:spAutoFit/>
-          </a:bodyPr>
-          <a:lstStyle/>
-          <a:p>
-            <a:pPr algn="l">
-              <a:spcAft>
-                <a:spcPts val="0"/>
-              </a:spcAft>
-              <a:defRPr sz="800" b="1">
-                <a:solidFill>
-                  <a:srgbClr val="999999"/>
-                </a:solidFill>
-                <a:latin typeface="Arial"/>
-              </a:defRPr>
-            </a:pPr>
-            <a:r>
-              <a:t>Budget</a:t>
-            </a:r>
-          </a:p>
-        </p:txBody>
-      </p:sp>
-      <p:sp>
-        <p:nvSpPr>
-          <p:cNvPr id="15" name="TextBox 14"/>
-          <p:cNvSpPr txBox="1"/>
-          <p:nvPr/>
-        </p:nvSpPr>
-        <p:spPr>
-          <a:xfrm>
-            <a:off x="8686800" y="1280160"/>
-            <a:ext cx="2468880" cy="182880"/>
-          </a:xfrm>
-          <a:prstGeom prst="rect">
-            <a:avLst/>
-          </a:prstGeom>
-          <a:noFill/>
-        </p:spPr>
-        <p:txBody>
-          <a:bodyPr wrap="square">
-            <a:spAutoFit/>
-          </a:bodyPr>
-          <a:lstStyle/>
-          <a:p>
-            <a:pPr algn="l">
-              <a:spcAft>
-                <a:spcPts val="0"/>
-              </a:spcAft>
-              <a:defRPr sz="1000" b="1">
-                <a:solidFill>
-                  <a:srgbClr val="1A1A1A"/>
-                </a:solidFill>
-                <a:latin typeface="Arial"/>
-              </a:defRPr>
-            </a:pPr>
-            <a:r>
-              <a:t>Kein dediziertes Budget nötig</a:t>
-            </a:r>
-          </a:p>
-        </p:txBody>
-      </p:sp>
-      <p:sp>
-        <p:nvSpPr>
-          <p:cNvPr id="16" name="TextBox 15"/>
-          <p:cNvSpPr txBox="1"/>
-          <p:nvPr/>
-        </p:nvSpPr>
-        <p:spPr>
-          <a:xfrm>
-            <a:off x="11338560" y="1097280"/>
-            <a:ext cx="2468880" cy="182880"/>
-          </a:xfrm>
-          <a:prstGeom prst="rect">
-            <a:avLst/>
-          </a:prstGeom>
-          <a:noFill/>
-        </p:spPr>
-        <p:txBody>
-          <a:bodyPr wrap="square">
-            <a:spAutoFit/>
-          </a:bodyPr>
-          <a:lstStyle/>
-          <a:p>
-            <a:pPr algn="l">
-              <a:spcAft>
-                <a:spcPts val="0"/>
-              </a:spcAft>
-              <a:defRPr sz="800" b="1">
-                <a:solidFill>
-                  <a:srgbClr val="999999"/>
-                </a:solidFill>
-                <a:latin typeface="Arial"/>
-              </a:defRPr>
-            </a:pPr>
-            <a:r>
-              <a:t>IT-Bedarf</a:t>
-            </a:r>
-          </a:p>
-        </p:txBody>
-      </p:sp>
-      <p:sp>
-        <p:nvSpPr>
-          <p:cNvPr id="17" name="TextBox 16"/>
-          <p:cNvSpPr txBox="1"/>
-          <p:nvPr/>
-        </p:nvSpPr>
-        <p:spPr>
-          <a:xfrm>
-            <a:off x="11338560" y="1280160"/>
-            <a:ext cx="2468880" cy="182880"/>
-          </a:xfrm>
-          <a:prstGeom prst="rect">
-            <a:avLst/>
-          </a:prstGeom>
-          <a:noFill/>
-        </p:spPr>
-        <p:txBody>
-          <a:bodyPr wrap="square">
-            <a:spAutoFit/>
-          </a:bodyPr>
-          <a:lstStyle/>
-          <a:p>
-            <a:pPr algn="l">
-              <a:spcAft>
-                <a:spcPts val="0"/>
-              </a:spcAft>
-              <a:defRPr sz="1000" b="1">
-                <a:solidFill>
-                  <a:srgbClr val="1A1A1A"/>
-                </a:solidFill>
-                <a:latin typeface="Arial"/>
-              </a:defRPr>
-            </a:pPr>
-            <a:r>
-              <a:t>Keiner</a:t>
+              <a:lnSpc>
+                <a:spcPts val="1650"/>
+              </a:lnSpc>
+              <a:spcAft>
+                <a:spcPts val="200"/>
+              </a:spcAft>
+              <a:defRPr sz="1100" b="0">
+                <a:solidFill>
+                  <a:srgbClr val="333333"/>
+                </a:solidFill>
+                <a:latin typeface="Arial"/>
+              </a:defRPr>
+            </a:pPr>
+            <a:r>
+              <a:t>Raiffeisen setzt bereits AI ein (Meeting-Vorbereitung, Chatbot Tina). Für die nächste</a:t>
+            </a:r>
+          </a:p>
+          <a:p>
+            <a:pPr algn="l">
+              <a:lnSpc>
+                <a:spcPts val="1650"/>
+              </a:lnSpc>
+              <a:spcAft>
+                <a:spcPts val="200"/>
+              </a:spcAft>
+              <a:defRPr sz="1100" b="0">
+                <a:solidFill>
+                  <a:srgbClr val="333333"/>
+                </a:solidFill>
+                <a:latin typeface="Arial"/>
+              </a:defRPr>
+            </a:pPr>
+            <a:r>
+              <a:t>Stufe — proaktive Kundenansprache, Berater-Training, Cross-Selling-Intelligenz —</a:t>
+            </a:r>
+          </a:p>
+          <a:p>
+            <a:pPr algn="l">
+              <a:lnSpc>
+                <a:spcPts val="1650"/>
+              </a:lnSpc>
+              <a:spcAft>
+                <a:spcPts val="200"/>
+              </a:spcAft>
+              <a:defRPr sz="1100" b="0">
+                <a:solidFill>
+                  <a:srgbClr val="333333"/>
+                </a:solidFill>
+                <a:latin typeface="Arial"/>
+              </a:defRPr>
+            </a:pPr>
+            <a:r>
+              <a:t>fehlt ein Partner mit Produktionserfahrung. Im März 2026 wurde vereinbart, einen</a:t>
+            </a:r>
+          </a:p>
+          <a:p>
+            <a:pPr algn="l">
+              <a:lnSpc>
+                <a:spcPts val="1650"/>
+              </a:lnSpc>
+              <a:spcAft>
+                <a:spcPts val="200"/>
+              </a:spcAft>
+              <a:defRPr sz="1100" b="0">
+                <a:solidFill>
+                  <a:srgbClr val="333333"/>
+                </a:solidFill>
+                <a:latin typeface="Arial"/>
+              </a:defRPr>
+            </a:pPr>
+            <a:r>
+              <a:t>leichtgewichtigen Pilotvorschlag zu erarbeiten, analog Allianz Suisse.</a:t>
             </a:r>
           </a:p>
         </p:txBody>
@@ -3738,8 +3796,8 @@
         </p:nvSpPr>
         <p:spPr>
           <a:xfrm>
-            <a:off x="731520" y="1554480"/>
-            <a:ext cx="13167360" cy="12700"/>
+            <a:off x="731520" y="2880360"/>
+            <a:ext cx="7772400" cy="12700"/>
           </a:xfrm>
           <a:prstGeom prst="rect">
             <a:avLst/>
@@ -3781,8 +3839,8 @@
         </p:nvSpPr>
         <p:spPr>
           <a:xfrm>
-            <a:off x="731520" y="1737360"/>
-            <a:ext cx="2743200" cy="182880"/>
+            <a:off x="731520" y="3063240"/>
+            <a:ext cx="3657600" cy="182880"/>
           </a:xfrm>
           <a:prstGeom prst="rect">
             <a:avLst/>
@@ -3807,7 +3865,7 @@
               </a:defRPr>
             </a:pPr>
             <a:r>
-              <a:t>AUSGANGSLAGE</a:t>
+              <a:t>VORSCHLAG</a:t>
             </a:r>
           </a:p>
         </p:txBody>
@@ -3820,8 +3878,8 @@
         </p:nvSpPr>
         <p:spPr>
           <a:xfrm>
-            <a:off x="731520" y="1965960"/>
-            <a:ext cx="6583680" cy="1280160"/>
+            <a:off x="731520" y="3291840"/>
+            <a:ext cx="7772400" cy="274320"/>
           </a:xfrm>
           <a:prstGeom prst="rect">
             <a:avLst/>
@@ -3835,13 +3893,10 @@
           <a:lstStyle/>
           <a:p>
             <a:pPr algn="l">
-              <a:lnSpc>
-                <a:spcPts val="1400"/>
-              </a:lnSpc>
-              <a:spcAft>
-                <a:spcPts val="200"/>
-              </a:spcAft>
-              <a:defRPr sz="1000" b="0">
+              <a:spcAft>
+                <a:spcPts val="0"/>
+              </a:spcAft>
+              <a:defRPr sz="1100" b="1">
                 <a:solidFill>
                   <a:srgbClr val="333333"/>
                 </a:solidFill>
@@ -3849,99 +3904,7 @@
               </a:defRPr>
             </a:pPr>
             <a:r>
-              <a:t>Raiffeisen investiert bereits in AI-Anwendungen (Meeting-Vorbereitung, Chatbot Tina).</a:t>
-            </a:r>
-          </a:p>
-          <a:p>
-            <a:pPr algn="l">
-              <a:lnSpc>
-                <a:spcPts val="1400"/>
-              </a:lnSpc>
-              <a:spcAft>
-                <a:spcPts val="200"/>
-              </a:spcAft>
-              <a:defRPr sz="1000" b="0">
-                <a:solidFill>
-                  <a:srgbClr val="333333"/>
-                </a:solidFill>
-                <a:latin typeface="Arial"/>
-              </a:defRPr>
-            </a:pPr>
-            <a:r>
-              <a:t>Für den nächsten Schritt — proaktive Kundenansprache, Berater-Training, Cross-Selling-</a:t>
-            </a:r>
-          </a:p>
-          <a:p>
-            <a:pPr algn="l">
-              <a:lnSpc>
-                <a:spcPts val="1400"/>
-              </a:lnSpc>
-              <a:spcAft>
-                <a:spcPts val="200"/>
-              </a:spcAft>
-              <a:defRPr sz="1000" b="0">
-                <a:solidFill>
-                  <a:srgbClr val="333333"/>
-                </a:solidFill>
-                <a:latin typeface="Arial"/>
-              </a:defRPr>
-            </a:pPr>
-            <a:r>
-              <a:t>Intelligenz — fehlt ein Partner mit Produktionserfahrung.</a:t>
-            </a:r>
-          </a:p>
-          <a:p>
-            <a:pPr algn="l">
-              <a:lnSpc>
-                <a:spcPts val="839"/>
-              </a:lnSpc>
-              <a:spcAft>
-                <a:spcPts val="200"/>
-              </a:spcAft>
-              <a:defRPr sz="600" b="0">
-                <a:solidFill>
-                  <a:srgbClr val="333333"/>
-                </a:solidFill>
-                <a:latin typeface="Arial"/>
-              </a:defRPr>
-            </a:pPr>
-          </a:p>
-          <a:p>
-            <a:pPr algn="l">
-              <a:lnSpc>
-                <a:spcPts val="1400"/>
-              </a:lnSpc>
-              <a:spcAft>
-                <a:spcPts val="200"/>
-              </a:spcAft>
-              <a:defRPr sz="1000" b="0">
-                <a:solidFill>
-                  <a:srgbClr val="333333"/>
-                </a:solidFill>
-                <a:latin typeface="Arial"/>
-              </a:defRPr>
-            </a:pPr>
-            <a:r>
-              <a:t>Im Austausch vom März 2026 wurde vereinbart, ein leichtgewichtiges Szenario</a:t>
-            </a:r>
-          </a:p>
-          <a:p>
-            <a:pPr algn="l">
-              <a:lnSpc>
-                <a:spcPts val="1400"/>
-              </a:lnSpc>
-              <a:spcAft>
-                <a:spcPts val="200"/>
-              </a:spcAft>
-              <a:defRPr sz="1000" b="0">
-                <a:solidFill>
-                  <a:srgbClr val="333333"/>
-                </a:solidFill>
-                <a:latin typeface="Arial"/>
-              </a:defRPr>
-            </a:pPr>
-            <a:r>
-              <a:t>vorzubereiten — analog zum Vorgehen bei Allianz Suisse (Test &amp; Learn, kein IT-Projekt).</a:t>
+              <a:t>Ein begrenzter Test-and-Learn-Pilot in 3 Schritten:</a:t>
             </a:r>
           </a:p>
         </p:txBody>
@@ -3954,8 +3917,8 @@
         </p:nvSpPr>
         <p:spPr>
           <a:xfrm>
-            <a:off x="731520" y="3063240"/>
-            <a:ext cx="2743200" cy="182880"/>
+            <a:off x="731520" y="3611880"/>
+            <a:ext cx="274320" cy="274320"/>
           </a:xfrm>
           <a:prstGeom prst="rect">
             <a:avLst/>
@@ -3972,7 +3935,7 @@
               <a:spcAft>
                 <a:spcPts val="0"/>
               </a:spcAft>
-              <a:defRPr sz="900" b="1">
+              <a:defRPr sz="1100" b="1">
                 <a:solidFill>
                   <a:srgbClr val="003366"/>
                 </a:solidFill>
@@ -3980,7 +3943,7 @@
               </a:defRPr>
             </a:pPr>
             <a:r>
-              <a:t>VORSCHLAG</a:t>
+              <a:t>1.</a:t>
             </a:r>
           </a:p>
         </p:txBody>
@@ -3993,8 +3956,8 @@
         </p:nvSpPr>
         <p:spPr>
           <a:xfrm>
-            <a:off x="731520" y="3291840"/>
-            <a:ext cx="6583680" cy="1645920"/>
+            <a:off x="1051560" y="3611880"/>
+            <a:ext cx="2011680" cy="274320"/>
           </a:xfrm>
           <a:prstGeom prst="rect">
             <a:avLst/>
@@ -4008,113 +3971,18 @@
           <a:lstStyle/>
           <a:p>
             <a:pPr algn="l">
-              <a:lnSpc>
-                <a:spcPts val="1400"/>
-              </a:lnSpc>
-              <a:spcAft>
-                <a:spcPts val="200"/>
-              </a:spcAft>
-              <a:defRPr sz="1000" b="1">
-                <a:solidFill>
-                  <a:srgbClr val="333333"/>
-                </a:solidFill>
-                <a:latin typeface="Arial"/>
-              </a:defRPr>
-            </a:pPr>
-            <a:r>
-              <a:t>Ein begrenzter Test-and-Learn-Pilot mit einem externen Partner (Salesteq).</a:t>
-            </a:r>
-          </a:p>
-          <a:p>
-            <a:pPr algn="l">
-              <a:lnSpc>
-                <a:spcPts val="1400"/>
-              </a:lnSpc>
-              <a:spcAft>
-                <a:spcPts val="200"/>
-              </a:spcAft>
-              <a:defRPr sz="1000" b="0">
-                <a:solidFill>
-                  <a:srgbClr val="333333"/>
-                </a:solidFill>
-                <a:latin typeface="Arial"/>
-              </a:defRPr>
-            </a:pPr>
-            <a:r>
-              <a:t>Ziel: Bewertungsgrundlage für den Einsatz von AI im Vertrieb schaffen.</a:t>
-            </a:r>
-          </a:p>
-          <a:p>
-            <a:pPr algn="l">
-              <a:lnSpc>
-                <a:spcPts val="839"/>
-              </a:lnSpc>
-              <a:spcAft>
-                <a:spcPts val="200"/>
-              </a:spcAft>
-              <a:defRPr sz="600" b="0">
-                <a:solidFill>
-                  <a:srgbClr val="333333"/>
-                </a:solidFill>
-                <a:latin typeface="Arial"/>
-              </a:defRPr>
-            </a:pPr>
-          </a:p>
-          <a:p>
-            <a:pPr algn="l">
-              <a:lnSpc>
-                <a:spcPts val="1400"/>
-              </a:lnSpc>
-              <a:spcAft>
-                <a:spcPts val="200"/>
-              </a:spcAft>
-              <a:defRPr sz="1000" b="0">
-                <a:solidFill>
-                  <a:srgbClr val="333333"/>
-                </a:solidFill>
-                <a:latin typeface="Arial"/>
-              </a:defRPr>
-            </a:pPr>
-            <a:r>
-              <a:t>Schritt 1: Workshop (½ Tag) — Use Cases identifizieren und priorisieren</a:t>
-            </a:r>
-          </a:p>
-          <a:p>
-            <a:pPr algn="l">
-              <a:lnSpc>
-                <a:spcPts val="1400"/>
-              </a:lnSpc>
-              <a:spcAft>
-                <a:spcPts val="200"/>
-              </a:spcAft>
-              <a:defRPr sz="1000" b="0">
-                <a:solidFill>
-                  <a:srgbClr val="333333"/>
-                </a:solidFill>
-                <a:latin typeface="Arial"/>
-              </a:defRPr>
-            </a:pPr>
-            <a:r>
-              <a:t>Schritt 2: Prototyp (6 Wochen) — Einen Use Case für eine Bank umsetzen</a:t>
-            </a:r>
-          </a:p>
-          <a:p>
-            <a:pPr algn="l">
-              <a:lnSpc>
-                <a:spcPts val="1400"/>
-              </a:lnSpc>
-              <a:spcAft>
-                <a:spcPts val="200"/>
-              </a:spcAft>
-              <a:defRPr sz="1000" b="0">
-                <a:solidFill>
-                  <a:srgbClr val="333333"/>
-                </a:solidFill>
-                <a:latin typeface="Arial"/>
-              </a:defRPr>
-            </a:pPr>
-            <a:r>
-              <a:t>Schritt 3: Bewertung — Ergebnisse messen, Feedback einholen, entscheiden</a:t>
+              <a:spcAft>
+                <a:spcPts val="0"/>
+              </a:spcAft>
+              <a:defRPr sz="1100" b="1">
+                <a:solidFill>
+                  <a:srgbClr val="1A1A1A"/>
+                </a:solidFill>
+                <a:latin typeface="Arial"/>
+              </a:defRPr>
+            </a:pPr>
+            <a:r>
+              <a:t>Workshop (½ Tag)</a:t>
             </a:r>
           </a:p>
         </p:txBody>
@@ -4127,8 +3995,8 @@
         </p:nvSpPr>
         <p:spPr>
           <a:xfrm>
-            <a:off x="731520" y="4434840"/>
-            <a:ext cx="2743200" cy="182880"/>
+            <a:off x="3200400" y="3611880"/>
+            <a:ext cx="5303520" cy="274320"/>
           </a:xfrm>
           <a:prstGeom prst="rect">
             <a:avLst/>
@@ -4145,7 +4013,46 @@
               <a:spcAft>
                 <a:spcPts val="0"/>
               </a:spcAft>
-              <a:defRPr sz="900" b="1">
+              <a:defRPr sz="1100" b="0">
+                <a:solidFill>
+                  <a:srgbClr val="777777"/>
+                </a:solidFill>
+                <a:latin typeface="Arial"/>
+              </a:defRPr>
+            </a:pPr>
+            <a:r>
+              <a:t>Use Cases gemeinsam identifizieren und priorisieren</a:t>
+            </a:r>
+          </a:p>
+        </p:txBody>
+      </p:sp>
+      <p:sp>
+        <p:nvSpPr>
+          <p:cNvPr id="24" name="TextBox 23"/>
+          <p:cNvSpPr txBox="1"/>
+          <p:nvPr/>
+        </p:nvSpPr>
+        <p:spPr>
+          <a:xfrm>
+            <a:off x="731520" y="4069080"/>
+            <a:ext cx="274320" cy="274320"/>
+          </a:xfrm>
+          <a:prstGeom prst="rect">
+            <a:avLst/>
+          </a:prstGeom>
+          <a:noFill/>
+        </p:spPr>
+        <p:txBody>
+          <a:bodyPr wrap="square">
+            <a:spAutoFit/>
+          </a:bodyPr>
+          <a:lstStyle/>
+          <a:p>
+            <a:pPr algn="l">
+              <a:spcAft>
+                <a:spcPts val="0"/>
+              </a:spcAft>
+              <a:defRPr sz="1100" b="1">
                 <a:solidFill>
                   <a:srgbClr val="003366"/>
                 </a:solidFill>
@@ -4153,29 +4060,222 @@
               </a:defRPr>
             </a:pPr>
             <a:r>
-              <a:t>MÖGLICHE USE CASES</a:t>
-            </a:r>
-          </a:p>
-        </p:txBody>
-      </p:sp>
-      <p:sp>
-        <p:nvSpPr>
-          <p:cNvPr id="24" name="Rounded Rectangle 23"/>
+              <a:t>2.</a:t>
+            </a:r>
+          </a:p>
+        </p:txBody>
+      </p:sp>
+      <p:sp>
+        <p:nvSpPr>
+          <p:cNvPr id="25" name="TextBox 24"/>
+          <p:cNvSpPr txBox="1"/>
+          <p:nvPr/>
+        </p:nvSpPr>
+        <p:spPr>
+          <a:xfrm>
+            <a:off x="1051560" y="4069080"/>
+            <a:ext cx="2011680" cy="274320"/>
+          </a:xfrm>
+          <a:prstGeom prst="rect">
+            <a:avLst/>
+          </a:prstGeom>
+          <a:noFill/>
+        </p:spPr>
+        <p:txBody>
+          <a:bodyPr wrap="square">
+            <a:spAutoFit/>
+          </a:bodyPr>
+          <a:lstStyle/>
+          <a:p>
+            <a:pPr algn="l">
+              <a:spcAft>
+                <a:spcPts val="0"/>
+              </a:spcAft>
+              <a:defRPr sz="1100" b="1">
+                <a:solidFill>
+                  <a:srgbClr val="1A1A1A"/>
+                </a:solidFill>
+                <a:latin typeface="Arial"/>
+              </a:defRPr>
+            </a:pPr>
+            <a:r>
+              <a:t>Prototyp (6 Wochen)</a:t>
+            </a:r>
+          </a:p>
+        </p:txBody>
+      </p:sp>
+      <p:sp>
+        <p:nvSpPr>
+          <p:cNvPr id="26" name="TextBox 25"/>
+          <p:cNvSpPr txBox="1"/>
+          <p:nvPr/>
+        </p:nvSpPr>
+        <p:spPr>
+          <a:xfrm>
+            <a:off x="3200400" y="4069080"/>
+            <a:ext cx="5303520" cy="274320"/>
+          </a:xfrm>
+          <a:prstGeom prst="rect">
+            <a:avLst/>
+          </a:prstGeom>
+          <a:noFill/>
+        </p:spPr>
+        <p:txBody>
+          <a:bodyPr wrap="square">
+            <a:spAutoFit/>
+          </a:bodyPr>
+          <a:lstStyle/>
+          <a:p>
+            <a:pPr algn="l">
+              <a:spcAft>
+                <a:spcPts val="0"/>
+              </a:spcAft>
+              <a:defRPr sz="1100" b="0">
+                <a:solidFill>
+                  <a:srgbClr val="777777"/>
+                </a:solidFill>
+                <a:latin typeface="Arial"/>
+              </a:defRPr>
+            </a:pPr>
+            <a:r>
+              <a:t>Einen Use Case für eine Raiffeisenbank umsetzen</a:t>
+            </a:r>
+          </a:p>
+        </p:txBody>
+      </p:sp>
+      <p:sp>
+        <p:nvSpPr>
+          <p:cNvPr id="27" name="TextBox 26"/>
+          <p:cNvSpPr txBox="1"/>
+          <p:nvPr/>
+        </p:nvSpPr>
+        <p:spPr>
+          <a:xfrm>
+            <a:off x="731520" y="4526280"/>
+            <a:ext cx="274320" cy="274320"/>
+          </a:xfrm>
+          <a:prstGeom prst="rect">
+            <a:avLst/>
+          </a:prstGeom>
+          <a:noFill/>
+        </p:spPr>
+        <p:txBody>
+          <a:bodyPr wrap="square">
+            <a:spAutoFit/>
+          </a:bodyPr>
+          <a:lstStyle/>
+          <a:p>
+            <a:pPr algn="l">
+              <a:spcAft>
+                <a:spcPts val="0"/>
+              </a:spcAft>
+              <a:defRPr sz="1100" b="1">
+                <a:solidFill>
+                  <a:srgbClr val="003366"/>
+                </a:solidFill>
+                <a:latin typeface="Arial"/>
+              </a:defRPr>
+            </a:pPr>
+            <a:r>
+              <a:t>3.</a:t>
+            </a:r>
+          </a:p>
+        </p:txBody>
+      </p:sp>
+      <p:sp>
+        <p:nvSpPr>
+          <p:cNvPr id="28" name="TextBox 27"/>
+          <p:cNvSpPr txBox="1"/>
+          <p:nvPr/>
+        </p:nvSpPr>
+        <p:spPr>
+          <a:xfrm>
+            <a:off x="1051560" y="4526280"/>
+            <a:ext cx="2011680" cy="274320"/>
+          </a:xfrm>
+          <a:prstGeom prst="rect">
+            <a:avLst/>
+          </a:prstGeom>
+          <a:noFill/>
+        </p:spPr>
+        <p:txBody>
+          <a:bodyPr wrap="square">
+            <a:spAutoFit/>
+          </a:bodyPr>
+          <a:lstStyle/>
+          <a:p>
+            <a:pPr algn="l">
+              <a:spcAft>
+                <a:spcPts val="0"/>
+              </a:spcAft>
+              <a:defRPr sz="1100" b="1">
+                <a:solidFill>
+                  <a:srgbClr val="1A1A1A"/>
+                </a:solidFill>
+                <a:latin typeface="Arial"/>
+              </a:defRPr>
+            </a:pPr>
+            <a:r>
+              <a:t>Bewertung</a:t>
+            </a:r>
+          </a:p>
+        </p:txBody>
+      </p:sp>
+      <p:sp>
+        <p:nvSpPr>
+          <p:cNvPr id="29" name="TextBox 28"/>
+          <p:cNvSpPr txBox="1"/>
+          <p:nvPr/>
+        </p:nvSpPr>
+        <p:spPr>
+          <a:xfrm>
+            <a:off x="3200400" y="4526280"/>
+            <a:ext cx="5303520" cy="274320"/>
+          </a:xfrm>
+          <a:prstGeom prst="rect">
+            <a:avLst/>
+          </a:prstGeom>
+          <a:noFill/>
+        </p:spPr>
+        <p:txBody>
+          <a:bodyPr wrap="square">
+            <a:spAutoFit/>
+          </a:bodyPr>
+          <a:lstStyle/>
+          <a:p>
+            <a:pPr algn="l">
+              <a:spcAft>
+                <a:spcPts val="0"/>
+              </a:spcAft>
+              <a:defRPr sz="1100" b="0">
+                <a:solidFill>
+                  <a:srgbClr val="777777"/>
+                </a:solidFill>
+                <a:latin typeface="Arial"/>
+              </a:defRPr>
+            </a:pPr>
+            <a:r>
+              <a:t>Ergebnisse messen, Feedback einholen, über nächste Schritte entscheiden</a:t>
+            </a:r>
+          </a:p>
+        </p:txBody>
+      </p:sp>
+      <p:sp>
+        <p:nvSpPr>
+          <p:cNvPr id="30" name="Rectangle 29"/>
           <p:cNvSpPr/>
           <p:nvPr/>
         </p:nvSpPr>
         <p:spPr>
           <a:xfrm>
-            <a:off x="731520" y="4663440"/>
-            <a:ext cx="3200400" cy="1188720"/>
-          </a:xfrm>
-          <a:prstGeom prst="roundRect">
-            <a:avLst>
-              <a:gd name="adj" fmla="val 3000"/>
-            </a:avLst>
+            <a:off x="731520" y="5074920"/>
+            <a:ext cx="7772400" cy="12700"/>
+          </a:xfrm>
+          <a:prstGeom prst="rect">
+            <a:avLst/>
           </a:prstGeom>
           <a:solidFill>
-            <a:srgbClr val="F7F7F7"/>
+            <a:srgbClr val="DDDDDD"/>
           </a:solidFill>
           <a:ln>
             <a:noFill/>
@@ -4205,14 +4305,14 @@
       </p:sp>
       <p:sp>
         <p:nvSpPr>
-          <p:cNvPr id="25" name="TextBox 24"/>
+          <p:cNvPr id="31" name="TextBox 30"/>
           <p:cNvSpPr txBox="1"/>
           <p:nvPr/>
         </p:nvSpPr>
         <p:spPr>
           <a:xfrm>
-            <a:off x="868680" y="4736592"/>
-            <a:ext cx="274320" cy="228600"/>
+            <a:off x="731520" y="5257800"/>
+            <a:ext cx="3657600" cy="182880"/>
           </a:xfrm>
           <a:prstGeom prst="rect">
             <a:avLst/>
@@ -4229,7 +4329,7 @@
               <a:spcAft>
                 <a:spcPts val="0"/>
               </a:spcAft>
-              <a:defRPr sz="1200" b="1">
+              <a:defRPr sz="900" b="1">
                 <a:solidFill>
                   <a:srgbClr val="003366"/>
                 </a:solidFill>
@@ -4237,21 +4337,21 @@
               </a:defRPr>
             </a:pPr>
             <a:r>
-              <a:t>A</a:t>
-            </a:r>
-          </a:p>
-        </p:txBody>
-      </p:sp>
-      <p:sp>
-        <p:nvSpPr>
-          <p:cNvPr id="26" name="TextBox 25"/>
+              <a:t>MÖGLICHE USE CASES</a:t>
+            </a:r>
+          </a:p>
+        </p:txBody>
+      </p:sp>
+      <p:sp>
+        <p:nvSpPr>
+          <p:cNvPr id="32" name="TextBox 31"/>
           <p:cNvSpPr txBox="1"/>
           <p:nvPr/>
         </p:nvSpPr>
         <p:spPr>
           <a:xfrm>
-            <a:off x="1143000" y="4736592"/>
-            <a:ext cx="2560320" cy="228600"/>
+            <a:off x="731520" y="5532120"/>
+            <a:ext cx="274320" cy="274320"/>
           </a:xfrm>
           <a:prstGeom prst="rect">
             <a:avLst/>
@@ -4268,29 +4368,29 @@
               <a:spcAft>
                 <a:spcPts val="0"/>
               </a:spcAft>
-              <a:defRPr sz="1000" b="1">
-                <a:solidFill>
-                  <a:srgbClr val="1A1A1A"/>
-                </a:solidFill>
-                <a:latin typeface="Arial"/>
-              </a:defRPr>
-            </a:pPr>
-            <a:r>
-              <a:t>Berater-Training</a:t>
-            </a:r>
-          </a:p>
-        </p:txBody>
-      </p:sp>
-      <p:sp>
-        <p:nvSpPr>
-          <p:cNvPr id="27" name="TextBox 26"/>
+              <a:defRPr sz="1100" b="1">
+                <a:solidFill>
+                  <a:srgbClr val="003366"/>
+                </a:solidFill>
+                <a:latin typeface="Arial"/>
+              </a:defRPr>
+            </a:pPr>
+            <a:r>
+              <a:t>A</a:t>
+            </a:r>
+          </a:p>
+        </p:txBody>
+      </p:sp>
+      <p:sp>
+        <p:nvSpPr>
+          <p:cNvPr id="33" name="TextBox 32"/>
           <p:cNvSpPr txBox="1"/>
           <p:nvPr/>
         </p:nvSpPr>
         <p:spPr>
           <a:xfrm>
-            <a:off x="868680" y="5029200"/>
-            <a:ext cx="2926080" cy="777240"/>
+            <a:off x="1051560" y="5532120"/>
+            <a:ext cx="2560320" cy="274320"/>
           </a:xfrm>
           <a:prstGeom prst="rect">
             <a:avLst/>
@@ -4307,45 +4407,425 @@
               <a:spcAft>
                 <a:spcPts val="0"/>
               </a:spcAft>
-              <a:defRPr sz="850" b="0">
-                <a:solidFill>
-                  <a:srgbClr val="666666"/>
-                </a:solidFill>
-                <a:latin typeface="Arial"/>
-              </a:defRPr>
-            </a:pPr>
-            <a:r>
-              <a:t>AI-Sparringspartner für neue und</a:t>
-            </a:r>
-            <a:br/>
-            <a:r>
-              <a:t>erfahrene RMs. Übungsgespräche,</a:t>
-            </a:r>
-            <a:br/>
-            <a:r>
-              <a:t>Produktwissen, SAQ-Vorbereitung.</a:t>
-            </a:r>
-          </a:p>
-        </p:txBody>
-      </p:sp>
-      <p:sp>
-        <p:nvSpPr>
-          <p:cNvPr id="28" name="Rounded Rectangle 27"/>
+              <a:defRPr sz="1000" b="1">
+                <a:solidFill>
+                  <a:srgbClr val="1A1A1A"/>
+                </a:solidFill>
+                <a:latin typeface="Arial"/>
+              </a:defRPr>
+            </a:pPr>
+            <a:r>
+              <a:t>Berater-Training &amp; Onboarding</a:t>
+            </a:r>
+          </a:p>
+        </p:txBody>
+      </p:sp>
+      <p:sp>
+        <p:nvSpPr>
+          <p:cNvPr id="34" name="TextBox 33"/>
+          <p:cNvSpPr txBox="1"/>
+          <p:nvPr/>
+        </p:nvSpPr>
+        <p:spPr>
+          <a:xfrm>
+            <a:off x="3749039" y="5532120"/>
+            <a:ext cx="4754880" cy="274320"/>
+          </a:xfrm>
+          <a:prstGeom prst="rect">
+            <a:avLst/>
+          </a:prstGeom>
+          <a:noFill/>
+        </p:spPr>
+        <p:txBody>
+          <a:bodyPr wrap="square">
+            <a:spAutoFit/>
+          </a:bodyPr>
+          <a:lstStyle/>
+          <a:p>
+            <a:pPr algn="l">
+              <a:spcAft>
+                <a:spcPts val="0"/>
+              </a:spcAft>
+              <a:defRPr sz="1000" b="0">
+                <a:solidFill>
+                  <a:srgbClr val="777777"/>
+                </a:solidFill>
+                <a:latin typeface="Arial"/>
+              </a:defRPr>
+            </a:pPr>
+            <a:r>
+              <a:t>AI als Sparringspartner für neue und erfahrene RMs</a:t>
+            </a:r>
+          </a:p>
+        </p:txBody>
+      </p:sp>
+      <p:sp>
+        <p:nvSpPr>
+          <p:cNvPr id="35" name="TextBox 34"/>
+          <p:cNvSpPr txBox="1"/>
+          <p:nvPr/>
+        </p:nvSpPr>
+        <p:spPr>
+          <a:xfrm>
+            <a:off x="731520" y="5989320"/>
+            <a:ext cx="274320" cy="274320"/>
+          </a:xfrm>
+          <a:prstGeom prst="rect">
+            <a:avLst/>
+          </a:prstGeom>
+          <a:noFill/>
+        </p:spPr>
+        <p:txBody>
+          <a:bodyPr wrap="square">
+            <a:spAutoFit/>
+          </a:bodyPr>
+          <a:lstStyle/>
+          <a:p>
+            <a:pPr algn="l">
+              <a:spcAft>
+                <a:spcPts val="0"/>
+              </a:spcAft>
+              <a:defRPr sz="1100" b="1">
+                <a:solidFill>
+                  <a:srgbClr val="003366"/>
+                </a:solidFill>
+                <a:latin typeface="Arial"/>
+              </a:defRPr>
+            </a:pPr>
+            <a:r>
+              <a:t>B</a:t>
+            </a:r>
+          </a:p>
+        </p:txBody>
+      </p:sp>
+      <p:sp>
+        <p:nvSpPr>
+          <p:cNvPr id="36" name="TextBox 35"/>
+          <p:cNvSpPr txBox="1"/>
+          <p:nvPr/>
+        </p:nvSpPr>
+        <p:spPr>
+          <a:xfrm>
+            <a:off x="1051560" y="5989320"/>
+            <a:ext cx="2560320" cy="274320"/>
+          </a:xfrm>
+          <a:prstGeom prst="rect">
+            <a:avLst/>
+          </a:prstGeom>
+          <a:noFill/>
+        </p:spPr>
+        <p:txBody>
+          <a:bodyPr wrap="square">
+            <a:spAutoFit/>
+          </a:bodyPr>
+          <a:lstStyle/>
+          <a:p>
+            <a:pPr algn="l">
+              <a:spcAft>
+                <a:spcPts val="0"/>
+              </a:spcAft>
+              <a:defRPr sz="1000" b="1">
+                <a:solidFill>
+                  <a:srgbClr val="1A1A1A"/>
+                </a:solidFill>
+                <a:latin typeface="Arial"/>
+              </a:defRPr>
+            </a:pPr>
+            <a:r>
+              <a:t>Proaktive Kundenansprache</a:t>
+            </a:r>
+          </a:p>
+        </p:txBody>
+      </p:sp>
+      <p:sp>
+        <p:nvSpPr>
+          <p:cNvPr id="37" name="TextBox 36"/>
+          <p:cNvSpPr txBox="1"/>
+          <p:nvPr/>
+        </p:nvSpPr>
+        <p:spPr>
+          <a:xfrm>
+            <a:off x="3749039" y="5989320"/>
+            <a:ext cx="4754880" cy="274320"/>
+          </a:xfrm>
+          <a:prstGeom prst="rect">
+            <a:avLst/>
+          </a:prstGeom>
+          <a:noFill/>
+        </p:spPr>
+        <p:txBody>
+          <a:bodyPr wrap="square">
+            <a:spAutoFit/>
+          </a:bodyPr>
+          <a:lstStyle/>
+          <a:p>
+            <a:pPr algn="l">
+              <a:spcAft>
+                <a:spcPts val="0"/>
+              </a:spcAft>
+              <a:defRPr sz="1000" b="0">
+                <a:solidFill>
+                  <a:srgbClr val="777777"/>
+                </a:solidFill>
+                <a:latin typeface="Arial"/>
+              </a:defRPr>
+            </a:pPr>
+            <a:r>
+              <a:t>Trigger-basiert bei Zinsänderungen, Festhypothek-Ablauf, Lebensereignissen</a:t>
+            </a:r>
+          </a:p>
+        </p:txBody>
+      </p:sp>
+      <p:sp>
+        <p:nvSpPr>
+          <p:cNvPr id="38" name="TextBox 37"/>
+          <p:cNvSpPr txBox="1"/>
+          <p:nvPr/>
+        </p:nvSpPr>
+        <p:spPr>
+          <a:xfrm>
+            <a:off x="731520" y="6446520"/>
+            <a:ext cx="274320" cy="274320"/>
+          </a:xfrm>
+          <a:prstGeom prst="rect">
+            <a:avLst/>
+          </a:prstGeom>
+          <a:noFill/>
+        </p:spPr>
+        <p:txBody>
+          <a:bodyPr wrap="square">
+            <a:spAutoFit/>
+          </a:bodyPr>
+          <a:lstStyle/>
+          <a:p>
+            <a:pPr algn="l">
+              <a:spcAft>
+                <a:spcPts val="0"/>
+              </a:spcAft>
+              <a:defRPr sz="1100" b="1">
+                <a:solidFill>
+                  <a:srgbClr val="003366"/>
+                </a:solidFill>
+                <a:latin typeface="Arial"/>
+              </a:defRPr>
+            </a:pPr>
+            <a:r>
+              <a:t>C</a:t>
+            </a:r>
+          </a:p>
+        </p:txBody>
+      </p:sp>
+      <p:sp>
+        <p:nvSpPr>
+          <p:cNvPr id="39" name="TextBox 38"/>
+          <p:cNvSpPr txBox="1"/>
+          <p:nvPr/>
+        </p:nvSpPr>
+        <p:spPr>
+          <a:xfrm>
+            <a:off x="1051560" y="6446520"/>
+            <a:ext cx="2560320" cy="274320"/>
+          </a:xfrm>
+          <a:prstGeom prst="rect">
+            <a:avLst/>
+          </a:prstGeom>
+          <a:noFill/>
+        </p:spPr>
+        <p:txBody>
+          <a:bodyPr wrap="square">
+            <a:spAutoFit/>
+          </a:bodyPr>
+          <a:lstStyle/>
+          <a:p>
+            <a:pPr algn="l">
+              <a:spcAft>
+                <a:spcPts val="0"/>
+              </a:spcAft>
+              <a:defRPr sz="1000" b="1">
+                <a:solidFill>
+                  <a:srgbClr val="1A1A1A"/>
+                </a:solidFill>
+                <a:latin typeface="Arial"/>
+              </a:defRPr>
+            </a:pPr>
+            <a:r>
+              <a:t>Produktwissen für 212 Banken</a:t>
+            </a:r>
+          </a:p>
+        </p:txBody>
+      </p:sp>
+      <p:sp>
+        <p:nvSpPr>
+          <p:cNvPr id="40" name="TextBox 39"/>
+          <p:cNvSpPr txBox="1"/>
+          <p:nvPr/>
+        </p:nvSpPr>
+        <p:spPr>
+          <a:xfrm>
+            <a:off x="3749039" y="6446520"/>
+            <a:ext cx="4754880" cy="274320"/>
+          </a:xfrm>
+          <a:prstGeom prst="rect">
+            <a:avLst/>
+          </a:prstGeom>
+          <a:noFill/>
+        </p:spPr>
+        <p:txBody>
+          <a:bodyPr wrap="square">
+            <a:spAutoFit/>
+          </a:bodyPr>
+          <a:lstStyle/>
+          <a:p>
+            <a:pPr algn="l">
+              <a:spcAft>
+                <a:spcPts val="0"/>
+              </a:spcAft>
+              <a:defRPr sz="1000" b="0">
+                <a:solidFill>
+                  <a:srgbClr val="777777"/>
+                </a:solidFill>
+                <a:latin typeface="Arial"/>
+              </a:defRPr>
+            </a:pPr>
+            <a:r>
+              <a:t>Einheitliche AI-Wissensbasis, immer aktuell, drei Sprachen</a:t>
+            </a:r>
+          </a:p>
+        </p:txBody>
+      </p:sp>
+      <p:sp>
+        <p:nvSpPr>
+          <p:cNvPr id="41" name="TextBox 40"/>
+          <p:cNvSpPr txBox="1"/>
+          <p:nvPr/>
+        </p:nvSpPr>
+        <p:spPr>
+          <a:xfrm>
+            <a:off x="731520" y="6903720"/>
+            <a:ext cx="274320" cy="274320"/>
+          </a:xfrm>
+          <a:prstGeom prst="rect">
+            <a:avLst/>
+          </a:prstGeom>
+          <a:noFill/>
+        </p:spPr>
+        <p:txBody>
+          <a:bodyPr wrap="square">
+            <a:spAutoFit/>
+          </a:bodyPr>
+          <a:lstStyle/>
+          <a:p>
+            <a:pPr algn="l">
+              <a:spcAft>
+                <a:spcPts val="0"/>
+              </a:spcAft>
+              <a:defRPr sz="1100" b="1">
+                <a:solidFill>
+                  <a:srgbClr val="003366"/>
+                </a:solidFill>
+                <a:latin typeface="Arial"/>
+              </a:defRPr>
+            </a:pPr>
+            <a:r>
+              <a:t>D</a:t>
+            </a:r>
+          </a:p>
+        </p:txBody>
+      </p:sp>
+      <p:sp>
+        <p:nvSpPr>
+          <p:cNvPr id="42" name="TextBox 41"/>
+          <p:cNvSpPr txBox="1"/>
+          <p:nvPr/>
+        </p:nvSpPr>
+        <p:spPr>
+          <a:xfrm>
+            <a:off x="1051560" y="6903720"/>
+            <a:ext cx="2560320" cy="274320"/>
+          </a:xfrm>
+          <a:prstGeom prst="rect">
+            <a:avLst/>
+          </a:prstGeom>
+          <a:noFill/>
+        </p:spPr>
+        <p:txBody>
+          <a:bodyPr wrap="square">
+            <a:spAutoFit/>
+          </a:bodyPr>
+          <a:lstStyle/>
+          <a:p>
+            <a:pPr algn="l">
+              <a:spcAft>
+                <a:spcPts val="0"/>
+              </a:spcAft>
+              <a:defRPr sz="1000" b="1">
+                <a:solidFill>
+                  <a:srgbClr val="1A1A1A"/>
+                </a:solidFill>
+                <a:latin typeface="Arial"/>
+              </a:defRPr>
+            </a:pPr>
+            <a:r>
+              <a:t>Erster Kundenkontakt</a:t>
+            </a:r>
+          </a:p>
+        </p:txBody>
+      </p:sp>
+      <p:sp>
+        <p:nvSpPr>
+          <p:cNvPr id="43" name="TextBox 42"/>
+          <p:cNvSpPr txBox="1"/>
+          <p:nvPr/>
+        </p:nvSpPr>
+        <p:spPr>
+          <a:xfrm>
+            <a:off x="3749039" y="6903720"/>
+            <a:ext cx="4754880" cy="274320"/>
+          </a:xfrm>
+          <a:prstGeom prst="rect">
+            <a:avLst/>
+          </a:prstGeom>
+          <a:noFill/>
+        </p:spPr>
+        <p:txBody>
+          <a:bodyPr wrap="square">
+            <a:spAutoFit/>
+          </a:bodyPr>
+          <a:lstStyle/>
+          <a:p>
+            <a:pPr algn="l">
+              <a:spcAft>
+                <a:spcPts val="0"/>
+              </a:spcAft>
+              <a:defRPr sz="1000" b="0">
+                <a:solidFill>
+                  <a:srgbClr val="777777"/>
+                </a:solidFill>
+                <a:latin typeface="Arial"/>
+              </a:defRPr>
+            </a:pPr>
+            <a:r>
+              <a:t>Chat und Telefon in DE/FR/IT, qualifizierte Weiterleitung an Berater</a:t>
+            </a:r>
+          </a:p>
+        </p:txBody>
+      </p:sp>
+      <p:sp>
+        <p:nvSpPr>
+          <p:cNvPr id="44" name="Rectangle 43"/>
           <p:cNvSpPr/>
           <p:nvPr/>
         </p:nvSpPr>
         <p:spPr>
           <a:xfrm>
-            <a:off x="4114800" y="4663440"/>
-            <a:ext cx="3200400" cy="1188720"/>
-          </a:xfrm>
-          <a:prstGeom prst="roundRect">
-            <a:avLst>
-              <a:gd name="adj" fmla="val 3000"/>
-            </a:avLst>
+            <a:off x="9144000" y="1417320"/>
+            <a:ext cx="4754880" cy="3383280"/>
+          </a:xfrm>
+          <a:prstGeom prst="rect">
+            <a:avLst/>
           </a:prstGeom>
           <a:solidFill>
-            <a:srgbClr val="F7F7F7"/>
+            <a:srgbClr val="EEF7F1"/>
           </a:solidFill>
           <a:ln>
             <a:noFill/>
@@ -4375,14 +4855,14 @@
       </p:sp>
       <p:sp>
         <p:nvSpPr>
-          <p:cNvPr id="29" name="TextBox 28"/>
+          <p:cNvPr id="45" name="TextBox 44"/>
           <p:cNvSpPr txBox="1"/>
           <p:nvPr/>
         </p:nvSpPr>
         <p:spPr>
           <a:xfrm>
-            <a:off x="4251960" y="4736592"/>
-            <a:ext cx="274320" cy="228600"/>
+            <a:off x="9372600" y="1508760"/>
+            <a:ext cx="4297680" cy="228600"/>
           </a:xfrm>
           <a:prstGeom prst="rect">
             <a:avLst/>
@@ -4399,29 +4879,29 @@
               <a:spcAft>
                 <a:spcPts val="0"/>
               </a:spcAft>
-              <a:defRPr sz="1200" b="1">
-                <a:solidFill>
-                  <a:srgbClr val="003366"/>
-                </a:solidFill>
-                <a:latin typeface="Arial"/>
-              </a:defRPr>
-            </a:pPr>
-            <a:r>
-              <a:t>B</a:t>
-            </a:r>
-          </a:p>
-        </p:txBody>
-      </p:sp>
-      <p:sp>
-        <p:nvSpPr>
-          <p:cNvPr id="30" name="TextBox 29"/>
+              <a:defRPr sz="900" b="1">
+                <a:solidFill>
+                  <a:srgbClr val="1D7A3F"/>
+                </a:solidFill>
+                <a:latin typeface="Arial"/>
+              </a:defRPr>
+            </a:pPr>
+            <a:r>
+              <a:t>WARUM KEIN IT-PROJEKT NÖTIG IST</a:t>
+            </a:r>
+          </a:p>
+        </p:txBody>
+      </p:sp>
+      <p:sp>
+        <p:nvSpPr>
+          <p:cNvPr id="46" name="TextBox 45"/>
           <p:cNvSpPr txBox="1"/>
           <p:nvPr/>
         </p:nvSpPr>
         <p:spPr>
           <a:xfrm>
-            <a:off x="4526280" y="4736592"/>
-            <a:ext cx="2560320" cy="228600"/>
+            <a:off x="9372600" y="1828800"/>
+            <a:ext cx="4297680" cy="182880"/>
           </a:xfrm>
           <a:prstGeom prst="rect">
             <a:avLst/>
@@ -4438,29 +4918,29 @@
               <a:spcAft>
                 <a:spcPts val="0"/>
               </a:spcAft>
-              <a:defRPr sz="1000" b="1">
-                <a:solidFill>
-                  <a:srgbClr val="1A1A1A"/>
-                </a:solidFill>
-                <a:latin typeface="Arial"/>
-              </a:defRPr>
-            </a:pPr>
-            <a:r>
-              <a:t>Proaktive Ansprache</a:t>
-            </a:r>
-          </a:p>
-        </p:txBody>
-      </p:sp>
-      <p:sp>
-        <p:nvSpPr>
-          <p:cNvPr id="31" name="TextBox 30"/>
+              <a:defRPr sz="900" b="1">
+                <a:solidFill>
+                  <a:srgbClr val="1D7A3F"/>
+                </a:solidFill>
+                <a:latin typeface="Arial"/>
+              </a:defRPr>
+            </a:pPr>
+            <a:r>
+              <a:t>✓  Kein Zugang zu Kernbanksystemen</a:t>
+            </a:r>
+          </a:p>
+        </p:txBody>
+      </p:sp>
+      <p:sp>
+        <p:nvSpPr>
+          <p:cNvPr id="47" name="TextBox 46"/>
           <p:cNvSpPr txBox="1"/>
           <p:nvPr/>
         </p:nvSpPr>
         <p:spPr>
           <a:xfrm>
-            <a:off x="4251960" y="5029200"/>
-            <a:ext cx="2926080" cy="777240"/>
+            <a:off x="9646920" y="2029968"/>
+            <a:ext cx="4023360" cy="411480"/>
           </a:xfrm>
           <a:prstGeom prst="rect">
             <a:avLst/>
@@ -4477,45 +4957,285 @@
               <a:spcAft>
                 <a:spcPts val="0"/>
               </a:spcAft>
-              <a:defRPr sz="850" b="0">
-                <a:solidFill>
-                  <a:srgbClr val="666666"/>
-                </a:solidFill>
-                <a:latin typeface="Arial"/>
-              </a:defRPr>
-            </a:pPr>
-            <a:r>
-              <a:t>Trigger-basierte Kundenkontakte bei</a:t>
+              <a:defRPr sz="800" b="0">
+                <a:solidFill>
+                  <a:srgbClr val="777777"/>
+                </a:solidFill>
+                <a:latin typeface="Arial"/>
+              </a:defRPr>
+            </a:pPr>
+            <a:r>
+              <a:t>Pilot läuft ausserhalb der bestehenden</a:t>
             </a:r>
             <a:br/>
             <a:r>
-              <a:t>Zinsänderungen, Festhypothek-Ablauf,</a:t>
+              <a:t>IT-Infrastruktur. Keine API-Anbindung.</a:t>
+            </a:r>
+          </a:p>
+        </p:txBody>
+      </p:sp>
+      <p:sp>
+        <p:nvSpPr>
+          <p:cNvPr id="48" name="TextBox 47"/>
+          <p:cNvSpPr txBox="1"/>
+          <p:nvPr/>
+        </p:nvSpPr>
+        <p:spPr>
+          <a:xfrm>
+            <a:off x="9372600" y="2542032"/>
+            <a:ext cx="4297680" cy="182880"/>
+          </a:xfrm>
+          <a:prstGeom prst="rect">
+            <a:avLst/>
+          </a:prstGeom>
+          <a:noFill/>
+        </p:spPr>
+        <p:txBody>
+          <a:bodyPr wrap="square">
+            <a:spAutoFit/>
+          </a:bodyPr>
+          <a:lstStyle/>
+          <a:p>
+            <a:pPr algn="l">
+              <a:spcAft>
+                <a:spcPts val="0"/>
+              </a:spcAft>
+              <a:defRPr sz="900" b="1">
+                <a:solidFill>
+                  <a:srgbClr val="1D7A3F"/>
+                </a:solidFill>
+                <a:latin typeface="Arial"/>
+              </a:defRPr>
+            </a:pPr>
+            <a:r>
+              <a:t>✓  Keine Kundendaten verlassen die Schweiz</a:t>
+            </a:r>
+          </a:p>
+        </p:txBody>
+      </p:sp>
+      <p:sp>
+        <p:nvSpPr>
+          <p:cNvPr id="49" name="TextBox 48"/>
+          <p:cNvSpPr txBox="1"/>
+          <p:nvPr/>
+        </p:nvSpPr>
+        <p:spPr>
+          <a:xfrm>
+            <a:off x="9646920" y="2743200"/>
+            <a:ext cx="4023360" cy="411480"/>
+          </a:xfrm>
+          <a:prstGeom prst="rect">
+            <a:avLst/>
+          </a:prstGeom>
+          <a:noFill/>
+        </p:spPr>
+        <p:txBody>
+          <a:bodyPr wrap="square">
+            <a:spAutoFit/>
+          </a:bodyPr>
+          <a:lstStyle/>
+          <a:p>
+            <a:pPr algn="l">
+              <a:spcAft>
+                <a:spcPts val="0"/>
+              </a:spcAft>
+              <a:defRPr sz="800" b="0">
+                <a:solidFill>
+                  <a:srgbClr val="777777"/>
+                </a:solidFill>
+                <a:latin typeface="Arial"/>
+              </a:defRPr>
+            </a:pPr>
+            <a:r>
+              <a:t>Infrastruktur in EU. Schweizer Hosting</a:t>
             </a:r>
             <a:br/>
             <a:r>
-              <a:t>Lebensereignissen. RM gibt frei.</a:t>
-            </a:r>
-          </a:p>
-        </p:txBody>
-      </p:sp>
-      <p:sp>
-        <p:nvSpPr>
-          <p:cNvPr id="32" name="Rounded Rectangle 31"/>
+              <a:t>oder On-Premise möglich.</a:t>
+            </a:r>
+          </a:p>
+        </p:txBody>
+      </p:sp>
+      <p:sp>
+        <p:nvSpPr>
+          <p:cNvPr id="50" name="TextBox 49"/>
+          <p:cNvSpPr txBox="1"/>
+          <p:nvPr/>
+        </p:nvSpPr>
+        <p:spPr>
+          <a:xfrm>
+            <a:off x="9372600" y="3255264"/>
+            <a:ext cx="4297680" cy="182880"/>
+          </a:xfrm>
+          <a:prstGeom prst="rect">
+            <a:avLst/>
+          </a:prstGeom>
+          <a:noFill/>
+        </p:spPr>
+        <p:txBody>
+          <a:bodyPr wrap="square">
+            <a:spAutoFit/>
+          </a:bodyPr>
+          <a:lstStyle/>
+          <a:p>
+            <a:pPr algn="l">
+              <a:spcAft>
+                <a:spcPts val="0"/>
+              </a:spcAft>
+              <a:defRPr sz="900" b="1">
+                <a:solidFill>
+                  <a:srgbClr val="1D7A3F"/>
+                </a:solidFill>
+                <a:latin typeface="Arial"/>
+              </a:defRPr>
+            </a:pPr>
+            <a:r>
+              <a:t>✓  Kein AI trifft autonome Entscheidungen</a:t>
+            </a:r>
+          </a:p>
+        </p:txBody>
+      </p:sp>
+      <p:sp>
+        <p:nvSpPr>
+          <p:cNvPr id="51" name="TextBox 50"/>
+          <p:cNvSpPr txBox="1"/>
+          <p:nvPr/>
+        </p:nvSpPr>
+        <p:spPr>
+          <a:xfrm>
+            <a:off x="9646920" y="3456432"/>
+            <a:ext cx="4023360" cy="411480"/>
+          </a:xfrm>
+          <a:prstGeom prst="rect">
+            <a:avLst/>
+          </a:prstGeom>
+          <a:noFill/>
+        </p:spPr>
+        <p:txBody>
+          <a:bodyPr wrap="square">
+            <a:spAutoFit/>
+          </a:bodyPr>
+          <a:lstStyle/>
+          <a:p>
+            <a:pPr algn="l">
+              <a:spcAft>
+                <a:spcPts val="0"/>
+              </a:spcAft>
+              <a:defRPr sz="800" b="0">
+                <a:solidFill>
+                  <a:srgbClr val="777777"/>
+                </a:solidFill>
+                <a:latin typeface="Arial"/>
+              </a:defRPr>
+            </a:pPr>
+            <a:r>
+              <a:t>Jede kundenseitige Aktion erfordert</a:t>
+            </a:r>
+            <a:br/>
+            <a:r>
+              <a:t>explizite Freigabe durch den RM.</a:t>
+            </a:r>
+          </a:p>
+        </p:txBody>
+      </p:sp>
+      <p:sp>
+        <p:nvSpPr>
+          <p:cNvPr id="52" name="TextBox 51"/>
+          <p:cNvSpPr txBox="1"/>
+          <p:nvPr/>
+        </p:nvSpPr>
+        <p:spPr>
+          <a:xfrm>
+            <a:off x="9372600" y="3968496"/>
+            <a:ext cx="4297680" cy="182880"/>
+          </a:xfrm>
+          <a:prstGeom prst="rect">
+            <a:avLst/>
+          </a:prstGeom>
+          <a:noFill/>
+        </p:spPr>
+        <p:txBody>
+          <a:bodyPr wrap="square">
+            <a:spAutoFit/>
+          </a:bodyPr>
+          <a:lstStyle/>
+          <a:p>
+            <a:pPr algn="l">
+              <a:spcAft>
+                <a:spcPts val="0"/>
+              </a:spcAft>
+              <a:defRPr sz="900" b="1">
+                <a:solidFill>
+                  <a:srgbClr val="1D7A3F"/>
+                </a:solidFill>
+                <a:latin typeface="Arial"/>
+              </a:defRPr>
+            </a:pPr>
+            <a:r>
+              <a:t>✓  Voller Audit-Trail</a:t>
+            </a:r>
+          </a:p>
+        </p:txBody>
+      </p:sp>
+      <p:sp>
+        <p:nvSpPr>
+          <p:cNvPr id="53" name="TextBox 52"/>
+          <p:cNvSpPr txBox="1"/>
+          <p:nvPr/>
+        </p:nvSpPr>
+        <p:spPr>
+          <a:xfrm>
+            <a:off x="9646920" y="4169663"/>
+            <a:ext cx="4023360" cy="411480"/>
+          </a:xfrm>
+          <a:prstGeom prst="rect">
+            <a:avLst/>
+          </a:prstGeom>
+          <a:noFill/>
+        </p:spPr>
+        <p:txBody>
+          <a:bodyPr wrap="square">
+            <a:spAutoFit/>
+          </a:bodyPr>
+          <a:lstStyle/>
+          <a:p>
+            <a:pPr algn="l">
+              <a:spcAft>
+                <a:spcPts val="0"/>
+              </a:spcAft>
+              <a:defRPr sz="800" b="0">
+                <a:solidFill>
+                  <a:srgbClr val="777777"/>
+                </a:solidFill>
+                <a:latin typeface="Arial"/>
+              </a:defRPr>
+            </a:pPr>
+            <a:r>
+              <a:t>Jede AI-Aktion protokolliert.</a:t>
+            </a:r>
+            <a:br/>
+            <a:r>
+              <a:t>Compliance-fähig.</a:t>
+            </a:r>
+          </a:p>
+        </p:txBody>
+      </p:sp>
+      <p:sp>
+        <p:nvSpPr>
+          <p:cNvPr id="54" name="Rectangle 53"/>
           <p:cNvSpPr/>
           <p:nvPr/>
         </p:nvSpPr>
         <p:spPr>
           <a:xfrm>
-            <a:off x="731520" y="5989320"/>
-            <a:ext cx="3200400" cy="1188720"/>
-          </a:xfrm>
-          <a:prstGeom prst="roundRect">
-            <a:avLst>
-              <a:gd name="adj" fmla="val 3000"/>
-            </a:avLst>
+            <a:off x="9144000" y="5074920"/>
+            <a:ext cx="4754880" cy="2240280"/>
+          </a:xfrm>
+          <a:prstGeom prst="rect">
+            <a:avLst/>
           </a:prstGeom>
           <a:solidFill>
-            <a:srgbClr val="F7F7F7"/>
+            <a:srgbClr val="FAFAFA"/>
           </a:solidFill>
           <a:ln>
             <a:noFill/>
@@ -4545,14 +5265,14 @@
       </p:sp>
       <p:sp>
         <p:nvSpPr>
-          <p:cNvPr id="33" name="TextBox 32"/>
+          <p:cNvPr id="55" name="TextBox 54"/>
           <p:cNvSpPr txBox="1"/>
           <p:nvPr/>
         </p:nvSpPr>
         <p:spPr>
           <a:xfrm>
-            <a:off x="868680" y="6062472"/>
-            <a:ext cx="274320" cy="228600"/>
+            <a:off x="9372600" y="5166360"/>
+            <a:ext cx="4297680" cy="228600"/>
           </a:xfrm>
           <a:prstGeom prst="rect">
             <a:avLst/>
@@ -4569,7 +5289,7 @@
               <a:spcAft>
                 <a:spcPts val="0"/>
               </a:spcAft>
-              <a:defRPr sz="1200" b="1">
+              <a:defRPr sz="900" b="1">
                 <a:solidFill>
                   <a:srgbClr val="003366"/>
                 </a:solidFill>
@@ -4577,21 +5297,21 @@
               </a:defRPr>
             </a:pPr>
             <a:r>
-              <a:t>C</a:t>
-            </a:r>
-          </a:p>
-        </p:txBody>
-      </p:sp>
-      <p:sp>
-        <p:nvSpPr>
-          <p:cNvPr id="34" name="TextBox 33"/>
+              <a:t>ÜBER DEN PARTNER</a:t>
+            </a:r>
+          </a:p>
+        </p:txBody>
+      </p:sp>
+      <p:sp>
+        <p:nvSpPr>
+          <p:cNvPr id="56" name="TextBox 55"/>
           <p:cNvSpPr txBox="1"/>
           <p:nvPr/>
         </p:nvSpPr>
         <p:spPr>
           <a:xfrm>
-            <a:off x="1143000" y="6062472"/>
-            <a:ext cx="2560320" cy="228600"/>
+            <a:off x="9372600" y="5440680"/>
+            <a:ext cx="4297680" cy="1828800"/>
           </a:xfrm>
           <a:prstGeom prst="rect">
             <a:avLst/>
@@ -4605,8 +5325,11 @@
           <a:lstStyle/>
           <a:p>
             <a:pPr algn="l">
-              <a:spcAft>
-                <a:spcPts val="0"/>
+              <a:lnSpc>
+                <a:spcPts val="1500"/>
+              </a:lnSpc>
+              <a:spcAft>
+                <a:spcPts val="200"/>
               </a:spcAft>
               <a:defRPr sz="1000" b="1">
                 <a:solidFill>
@@ -4616,76 +5339,173 @@
               </a:defRPr>
             </a:pPr>
             <a:r>
-              <a:t>Produktwissen</a:t>
-            </a:r>
-          </a:p>
-        </p:txBody>
-      </p:sp>
-      <p:sp>
-        <p:nvSpPr>
-          <p:cNvPr id="35" name="TextBox 34"/>
-          <p:cNvSpPr txBox="1"/>
-          <p:nvPr/>
-        </p:nvSpPr>
-        <p:spPr>
-          <a:xfrm>
-            <a:off x="868680" y="6355080"/>
-            <a:ext cx="2926080" cy="777240"/>
-          </a:xfrm>
-          <a:prstGeom prst="rect">
-            <a:avLst/>
-          </a:prstGeom>
-          <a:noFill/>
-        </p:spPr>
-        <p:txBody>
-          <a:bodyPr wrap="square">
-            <a:spAutoFit/>
-          </a:bodyPr>
-          <a:lstStyle/>
-          <a:p>
-            <a:pPr algn="l">
-              <a:spcAft>
-                <a:spcPts val="0"/>
+              <a:t>Salesteq (Elyon GmbH, Zug)</a:t>
+            </a:r>
+          </a:p>
+          <a:p>
+            <a:pPr algn="l">
+              <a:lnSpc>
+                <a:spcPts val="1350"/>
+              </a:lnSpc>
+              <a:spcAft>
+                <a:spcPts val="200"/>
+              </a:spcAft>
+              <a:defRPr sz="900" b="0">
+                <a:solidFill>
+                  <a:srgbClr val="777777"/>
+                </a:solidFill>
+                <a:latin typeface="Arial"/>
+              </a:defRPr>
+            </a:pPr>
+            <a:r>
+              <a:t>AI-Plattform für Vertrieb, Marketing, Kundenservice.</a:t>
+            </a:r>
+          </a:p>
+          <a:p>
+            <a:pPr algn="l">
+              <a:lnSpc>
+                <a:spcPts val="750"/>
+              </a:lnSpc>
+              <a:spcAft>
+                <a:spcPts val="200"/>
+              </a:spcAft>
+              <a:defRPr sz="500" b="0">
+                <a:solidFill>
+                  <a:srgbClr val="777777"/>
+                </a:solidFill>
+                <a:latin typeface="Arial"/>
+              </a:defRPr>
+            </a:pPr>
+          </a:p>
+          <a:p>
+            <a:pPr algn="l">
+              <a:lnSpc>
+                <a:spcPts val="1350"/>
+              </a:lnSpc>
+              <a:spcAft>
+                <a:spcPts val="200"/>
+              </a:spcAft>
+              <a:defRPr sz="900" b="1">
+                <a:solidFill>
+                  <a:srgbClr val="1A1A1A"/>
+                </a:solidFill>
+                <a:latin typeface="Arial"/>
+              </a:defRPr>
+            </a:pPr>
+            <a:r>
+              <a:t>Referenzen:</a:t>
+            </a:r>
+          </a:p>
+          <a:p>
+            <a:pPr algn="l">
+              <a:lnSpc>
+                <a:spcPts val="1275"/>
+              </a:lnSpc>
+              <a:spcAft>
+                <a:spcPts val="200"/>
               </a:spcAft>
               <a:defRPr sz="850" b="0">
                 <a:solidFill>
-                  <a:srgbClr val="666666"/>
-                </a:solidFill>
-                <a:latin typeface="Arial"/>
-              </a:defRPr>
-            </a:pPr>
-            <a:r>
-              <a:t>Einheitliche AI-Wissensbasis über</a:t>
-            </a:r>
-            <a:br/>
-            <a:r>
-              <a:t>alle 212 Banken. Immer aktuell,</a:t>
-            </a:r>
-            <a:br/>
-            <a:r>
-              <a:t>drei Sprachen, audit-fähig.</a:t>
-            </a:r>
-          </a:p>
-        </p:txBody>
-      </p:sp>
-      <p:sp>
-        <p:nvSpPr>
-          <p:cNvPr id="36" name="Rounded Rectangle 35"/>
+                  <a:srgbClr val="777777"/>
+                </a:solidFill>
+                <a:latin typeface="Arial"/>
+              </a:defRPr>
+            </a:pPr>
+            <a:r>
+              <a:t>· Naghi/BMW Saudi-Arabien — Produktion, Voice AI</a:t>
+            </a:r>
+          </a:p>
+          <a:p>
+            <a:pPr algn="l">
+              <a:lnSpc>
+                <a:spcPts val="1275"/>
+              </a:lnSpc>
+              <a:spcAft>
+                <a:spcPts val="200"/>
+              </a:spcAft>
+              <a:defRPr sz="850" b="0">
+                <a:solidFill>
+                  <a:srgbClr val="777777"/>
+                </a:solidFill>
+                <a:latin typeface="Arial"/>
+              </a:defRPr>
+            </a:pPr>
+            <a:r>
+              <a:t>· Suhner Abrasive (CH) — AI-Verkaufsassistent</a:t>
+            </a:r>
+          </a:p>
+          <a:p>
+            <a:pPr algn="l">
+              <a:lnSpc>
+                <a:spcPts val="1275"/>
+              </a:lnSpc>
+              <a:spcAft>
+                <a:spcPts val="200"/>
+              </a:spcAft>
+              <a:defRPr sz="850" b="0">
+                <a:solidFill>
+                  <a:srgbClr val="777777"/>
+                </a:solidFill>
+                <a:latin typeface="Arial"/>
+              </a:defRPr>
+            </a:pPr>
+            <a:r>
+              <a:t>· Allianz Suisse — Test &amp; Learn Pilot</a:t>
+            </a:r>
+          </a:p>
+          <a:p>
+            <a:pPr algn="l">
+              <a:lnSpc>
+                <a:spcPts val="750"/>
+              </a:lnSpc>
+              <a:spcAft>
+                <a:spcPts val="200"/>
+              </a:spcAft>
+              <a:defRPr sz="500" b="0">
+                <a:solidFill>
+                  <a:srgbClr val="777777"/>
+                </a:solidFill>
+                <a:latin typeface="Arial"/>
+              </a:defRPr>
+            </a:pPr>
+          </a:p>
+          <a:p>
+            <a:pPr algn="l">
+              <a:lnSpc>
+                <a:spcPts val="1275"/>
+              </a:lnSpc>
+              <a:spcAft>
+                <a:spcPts val="200"/>
+              </a:spcAft>
+              <a:defRPr sz="850" b="0">
+                <a:solidFill>
+                  <a:srgbClr val="777777"/>
+                </a:solidFill>
+                <a:latin typeface="Arial"/>
+              </a:defRPr>
+            </a:pPr>
+            <a:r>
+              <a:t>NVIDIA Inception Member. Eigene Sprach-Engine.</a:t>
+            </a:r>
+          </a:p>
+        </p:txBody>
+      </p:sp>
+      <p:sp>
+        <p:nvSpPr>
+          <p:cNvPr id="57" name="Rectangle 56"/>
           <p:cNvSpPr/>
           <p:nvPr/>
         </p:nvSpPr>
         <p:spPr>
           <a:xfrm>
-            <a:off x="4114800" y="5989320"/>
-            <a:ext cx="3200400" cy="1188720"/>
-          </a:xfrm>
-          <a:prstGeom prst="roundRect">
-            <a:avLst>
-              <a:gd name="adj" fmla="val 3000"/>
-            </a:avLst>
+            <a:off x="731520" y="7452360"/>
+            <a:ext cx="13167360" cy="502920"/>
+          </a:xfrm>
+          <a:prstGeom prst="rect">
+            <a:avLst/>
           </a:prstGeom>
           <a:solidFill>
-            <a:srgbClr val="F7F7F7"/>
+            <a:srgbClr val="003366"/>
           </a:solidFill>
           <a:ln>
             <a:noFill/>
@@ -4715,14 +5535,14 @@
       </p:sp>
       <p:sp>
         <p:nvSpPr>
-          <p:cNvPr id="37" name="TextBox 36"/>
+          <p:cNvPr id="58" name="TextBox 57"/>
           <p:cNvSpPr txBox="1"/>
           <p:nvPr/>
         </p:nvSpPr>
         <p:spPr>
           <a:xfrm>
-            <a:off x="4251960" y="6062472"/>
-            <a:ext cx="274320" cy="228600"/>
+            <a:off x="914400" y="7498079"/>
+            <a:ext cx="2743200" cy="182880"/>
           </a:xfrm>
           <a:prstGeom prst="rect">
             <a:avLst/>
@@ -4739,29 +5559,29 @@
               <a:spcAft>
                 <a:spcPts val="0"/>
               </a:spcAft>
-              <a:defRPr sz="1200" b="1">
-                <a:solidFill>
-                  <a:srgbClr val="003366"/>
-                </a:solidFill>
-                <a:latin typeface="Arial"/>
-              </a:defRPr>
-            </a:pPr>
-            <a:r>
-              <a:t>D</a:t>
-            </a:r>
-          </a:p>
-        </p:txBody>
-      </p:sp>
-      <p:sp>
-        <p:nvSpPr>
-          <p:cNvPr id="38" name="TextBox 37"/>
+              <a:defRPr sz="800" b="1">
+                <a:solidFill>
+                  <a:srgbClr val="88AACC"/>
+                </a:solidFill>
+                <a:latin typeface="Arial"/>
+              </a:defRPr>
+            </a:pPr>
+            <a:r>
+              <a:t>NÄCHSTER SCHRITT</a:t>
+            </a:r>
+          </a:p>
+        </p:txBody>
+      </p:sp>
+      <p:sp>
+        <p:nvSpPr>
+          <p:cNvPr id="59" name="TextBox 58"/>
           <p:cNvSpPr txBox="1"/>
           <p:nvPr/>
         </p:nvSpPr>
         <p:spPr>
           <a:xfrm>
-            <a:off x="4526280" y="6062472"/>
-            <a:ext cx="2560320" cy="228600"/>
+            <a:off x="914400" y="7680960"/>
+            <a:ext cx="8229600" cy="228600"/>
           </a:xfrm>
           <a:prstGeom prst="rect">
             <a:avLst/>
@@ -4778,29 +5598,29 @@
               <a:spcAft>
                 <a:spcPts val="0"/>
               </a:spcAft>
-              <a:defRPr sz="1000" b="1">
-                <a:solidFill>
-                  <a:srgbClr val="1A1A1A"/>
-                </a:solidFill>
-                <a:latin typeface="Arial"/>
-              </a:defRPr>
-            </a:pPr>
-            <a:r>
-              <a:t>Erster Kundenkontakt</a:t>
-            </a:r>
-          </a:p>
-        </p:txBody>
-      </p:sp>
-      <p:sp>
-        <p:nvSpPr>
-          <p:cNvPr id="39" name="TextBox 38"/>
+              <a:defRPr sz="1100" b="1">
+                <a:solidFill>
+                  <a:srgbClr val="FFFFFF"/>
+                </a:solidFill>
+                <a:latin typeface="Arial"/>
+              </a:defRPr>
+            </a:pPr>
+            <a:r>
+              <a:t>90-Minuten-Gespräch mit einem Kundenberater Ihrer Wahl. Wir hören zu. Kein Vertrag, keine Kosten.</a:t>
+            </a:r>
+          </a:p>
+        </p:txBody>
+      </p:sp>
+      <p:sp>
+        <p:nvSpPr>
+          <p:cNvPr id="60" name="TextBox 59"/>
           <p:cNvSpPr txBox="1"/>
           <p:nvPr/>
         </p:nvSpPr>
         <p:spPr>
           <a:xfrm>
-            <a:off x="4251960" y="6355080"/>
-            <a:ext cx="2926080" cy="777240"/>
+            <a:off x="10058400" y="7589520"/>
+            <a:ext cx="3840480" cy="274320"/>
           </a:xfrm>
           <a:prstGeom prst="rect">
             <a:avLst/>
@@ -4813,888 +5633,11 @@
           </a:bodyPr>
           <a:lstStyle/>
           <a:p>
-            <a:pPr algn="l">
+            <a:pPr algn="r">
               <a:spcAft>
                 <a:spcPts val="0"/>
               </a:spcAft>
-              <a:defRPr sz="850" b="0">
-                <a:solidFill>
-                  <a:srgbClr val="666666"/>
-                </a:solidFill>
-                <a:latin typeface="Arial"/>
-              </a:defRPr>
-            </a:pPr>
-            <a:r>
-              <a:t>Routineanfragen per Chat und Telefon</a:t>
-            </a:r>
-            <a:br/>
-            <a:r>
-              <a:t>automatisiert. DE/FR/IT.</a:t>
-            </a:r>
-            <a:br/>
-            <a:r>
-              <a:t>Komplexes an RM weitergeleitet.</a:t>
-            </a:r>
-          </a:p>
-        </p:txBody>
-      </p:sp>
-      <p:sp>
-        <p:nvSpPr>
-          <p:cNvPr id="40" name="TextBox 39"/>
-          <p:cNvSpPr txBox="1"/>
-          <p:nvPr/>
-        </p:nvSpPr>
-        <p:spPr>
-          <a:xfrm>
-            <a:off x="7772400" y="1737360"/>
-            <a:ext cx="4572000" cy="182880"/>
-          </a:xfrm>
-          <a:prstGeom prst="rect">
-            <a:avLst/>
-          </a:prstGeom>
-          <a:noFill/>
-        </p:spPr>
-        <p:txBody>
-          <a:bodyPr wrap="square">
-            <a:spAutoFit/>
-          </a:bodyPr>
-          <a:lstStyle/>
-          <a:p>
-            <a:pPr algn="l">
-              <a:spcAft>
-                <a:spcPts val="0"/>
-              </a:spcAft>
-              <a:defRPr sz="900" b="1">
-                <a:solidFill>
-                  <a:srgbClr val="003366"/>
-                </a:solidFill>
-                <a:latin typeface="Arial"/>
-              </a:defRPr>
-            </a:pPr>
-            <a:r>
-              <a:t>IT- UND SICHERHEITSASPEKTE</a:t>
-            </a:r>
-          </a:p>
-        </p:txBody>
-      </p:sp>
-      <p:sp>
-        <p:nvSpPr>
-          <p:cNvPr id="41" name="Rounded Rectangle 40"/>
-          <p:cNvSpPr/>
-          <p:nvPr/>
-        </p:nvSpPr>
-        <p:spPr>
-          <a:xfrm>
-            <a:off x="7772400" y="1965960"/>
-            <a:ext cx="6126480" cy="2743200"/>
-          </a:xfrm>
-          <a:prstGeom prst="roundRect">
-            <a:avLst>
-              <a:gd name="adj" fmla="val 3000"/>
-            </a:avLst>
-          </a:prstGeom>
-          <a:solidFill>
-            <a:srgbClr val="ECF7F0"/>
-          </a:solidFill>
-          <a:ln>
-            <a:noFill/>
-          </a:ln>
-        </p:spPr>
-        <p:style>
-          <a:lnRef idx="1">
-            <a:schemeClr val="accent1"/>
-          </a:lnRef>
-          <a:fillRef idx="3">
-            <a:schemeClr val="accent1"/>
-          </a:fillRef>
-          <a:effectRef idx="2">
-            <a:schemeClr val="accent1"/>
-          </a:effectRef>
-          <a:fontRef idx="minor">
-            <a:schemeClr val="lt1"/>
-          </a:fontRef>
-        </p:style>
-        <p:txBody>
-          <a:bodyPr rtlCol="0" anchor="ctr"/>
-          <a:lstStyle/>
-          <a:p>
-            <a:pPr algn="ctr"/>
-          </a:p>
-        </p:txBody>
-      </p:sp>
-      <p:sp>
-        <p:nvSpPr>
-          <p:cNvPr id="42" name="TextBox 41"/>
-          <p:cNvSpPr txBox="1"/>
-          <p:nvPr/>
-        </p:nvSpPr>
-        <p:spPr>
-          <a:xfrm>
-            <a:off x="7955279" y="2057400"/>
-            <a:ext cx="5760720" cy="182880"/>
-          </a:xfrm>
-          <a:prstGeom prst="rect">
-            <a:avLst/>
-          </a:prstGeom>
-          <a:noFill/>
-        </p:spPr>
-        <p:txBody>
-          <a:bodyPr wrap="square">
-            <a:spAutoFit/>
-          </a:bodyPr>
-          <a:lstStyle/>
-          <a:p>
-            <a:pPr algn="l">
-              <a:spcAft>
-                <a:spcPts val="0"/>
-              </a:spcAft>
-              <a:defRPr sz="1000" b="1">
-                <a:solidFill>
-                  <a:srgbClr val="16803C"/>
-                </a:solidFill>
-                <a:latin typeface="Arial"/>
-              </a:defRPr>
-            </a:pPr>
-            <a:r>
-              <a:t>Warum kein IT-Projekt nötig ist:</a:t>
-            </a:r>
-          </a:p>
-        </p:txBody>
-      </p:sp>
-      <p:sp>
-        <p:nvSpPr>
-          <p:cNvPr id="43" name="TextBox 42"/>
-          <p:cNvSpPr txBox="1"/>
-          <p:nvPr/>
-        </p:nvSpPr>
-        <p:spPr>
-          <a:xfrm>
-            <a:off x="7955279" y="2331720"/>
-            <a:ext cx="5760720" cy="182880"/>
-          </a:xfrm>
-          <a:prstGeom prst="rect">
-            <a:avLst/>
-          </a:prstGeom>
-          <a:noFill/>
-        </p:spPr>
-        <p:txBody>
-          <a:bodyPr wrap="square">
-            <a:spAutoFit/>
-          </a:bodyPr>
-          <a:lstStyle/>
-          <a:p>
-            <a:pPr algn="l">
-              <a:spcAft>
-                <a:spcPts val="0"/>
-              </a:spcAft>
-              <a:defRPr sz="900" b="1">
-                <a:solidFill>
-                  <a:srgbClr val="16803C"/>
-                </a:solidFill>
-                <a:latin typeface="Arial"/>
-              </a:defRPr>
-            </a:pPr>
-            <a:r>
-              <a:t>✓  Kein Zugang zu Kernbanksystemen</a:t>
-            </a:r>
-          </a:p>
-        </p:txBody>
-      </p:sp>
-      <p:sp>
-        <p:nvSpPr>
-          <p:cNvPr id="44" name="TextBox 43"/>
-          <p:cNvSpPr txBox="1"/>
-          <p:nvPr/>
-        </p:nvSpPr>
-        <p:spPr>
-          <a:xfrm>
-            <a:off x="8321040" y="2514600"/>
-            <a:ext cx="5394960" cy="228600"/>
-          </a:xfrm>
-          <a:prstGeom prst="rect">
-            <a:avLst/>
-          </a:prstGeom>
-          <a:noFill/>
-        </p:spPr>
-        <p:txBody>
-          <a:bodyPr wrap="square">
-            <a:spAutoFit/>
-          </a:bodyPr>
-          <a:lstStyle/>
-          <a:p>
-            <a:pPr algn="l">
-              <a:spcAft>
-                <a:spcPts val="0"/>
-              </a:spcAft>
-              <a:defRPr sz="750" b="0">
-                <a:solidFill>
-                  <a:srgbClr val="666666"/>
-                </a:solidFill>
-                <a:latin typeface="Arial"/>
-              </a:defRPr>
-            </a:pPr>
-            <a:r>
-              <a:t>Der Pilot läuft vollständig ausserhalb der bestehenden IT-Infrastruktur. Keine API-Anbindung an Avaloq, BSI oder andere Kernsysteme nötig.</a:t>
-            </a:r>
-          </a:p>
-        </p:txBody>
-      </p:sp>
-      <p:sp>
-        <p:nvSpPr>
-          <p:cNvPr id="45" name="TextBox 44"/>
-          <p:cNvSpPr txBox="1"/>
-          <p:nvPr/>
-        </p:nvSpPr>
-        <p:spPr>
-          <a:xfrm>
-            <a:off x="7955279" y="2788920"/>
-            <a:ext cx="5760720" cy="182880"/>
-          </a:xfrm>
-          <a:prstGeom prst="rect">
-            <a:avLst/>
-          </a:prstGeom>
-          <a:noFill/>
-        </p:spPr>
-        <p:txBody>
-          <a:bodyPr wrap="square">
-            <a:spAutoFit/>
-          </a:bodyPr>
-          <a:lstStyle/>
-          <a:p>
-            <a:pPr algn="l">
-              <a:spcAft>
-                <a:spcPts val="0"/>
-              </a:spcAft>
-              <a:defRPr sz="900" b="1">
-                <a:solidFill>
-                  <a:srgbClr val="16803C"/>
-                </a:solidFill>
-                <a:latin typeface="Arial"/>
-              </a:defRPr>
-            </a:pPr>
-            <a:r>
-              <a:t>✓  Keine Kundendaten verlassen die Schweiz</a:t>
-            </a:r>
-          </a:p>
-        </p:txBody>
-      </p:sp>
-      <p:sp>
-        <p:nvSpPr>
-          <p:cNvPr id="46" name="TextBox 45"/>
-          <p:cNvSpPr txBox="1"/>
-          <p:nvPr/>
-        </p:nvSpPr>
-        <p:spPr>
-          <a:xfrm>
-            <a:off x="8321040" y="2971800"/>
-            <a:ext cx="5394960" cy="228600"/>
-          </a:xfrm>
-          <a:prstGeom prst="rect">
-            <a:avLst/>
-          </a:prstGeom>
-          <a:noFill/>
-        </p:spPr>
-        <p:txBody>
-          <a:bodyPr wrap="square">
-            <a:spAutoFit/>
-          </a:bodyPr>
-          <a:lstStyle/>
-          <a:p>
-            <a:pPr algn="l">
-              <a:spcAft>
-                <a:spcPts val="0"/>
-              </a:spcAft>
-              <a:defRPr sz="750" b="0">
-                <a:solidFill>
-                  <a:srgbClr val="666666"/>
-                </a:solidFill>
-                <a:latin typeface="Arial"/>
-              </a:defRPr>
-            </a:pPr>
-            <a:r>
-              <a:t>Infrastruktur auf Hetzner (EU/Deutschland). Schweizer Hosting oder On-Premise-Deployment architektonisch vorgesehen.</a:t>
-            </a:r>
-          </a:p>
-        </p:txBody>
-      </p:sp>
-      <p:sp>
-        <p:nvSpPr>
-          <p:cNvPr id="47" name="TextBox 46"/>
-          <p:cNvSpPr txBox="1"/>
-          <p:nvPr/>
-        </p:nvSpPr>
-        <p:spPr>
-          <a:xfrm>
-            <a:off x="7955279" y="3246120"/>
-            <a:ext cx="5760720" cy="182880"/>
-          </a:xfrm>
-          <a:prstGeom prst="rect">
-            <a:avLst/>
-          </a:prstGeom>
-          <a:noFill/>
-        </p:spPr>
-        <p:txBody>
-          <a:bodyPr wrap="square">
-            <a:spAutoFit/>
-          </a:bodyPr>
-          <a:lstStyle/>
-          <a:p>
-            <a:pPr algn="l">
-              <a:spcAft>
-                <a:spcPts val="0"/>
-              </a:spcAft>
-              <a:defRPr sz="900" b="1">
-                <a:solidFill>
-                  <a:srgbClr val="16803C"/>
-                </a:solidFill>
-                <a:latin typeface="Arial"/>
-              </a:defRPr>
-            </a:pPr>
-            <a:r>
-              <a:t>✓  Kein AI-Modell trifft autonome Entscheidungen</a:t>
-            </a:r>
-          </a:p>
-        </p:txBody>
-      </p:sp>
-      <p:sp>
-        <p:nvSpPr>
-          <p:cNvPr id="48" name="TextBox 47"/>
-          <p:cNvSpPr txBox="1"/>
-          <p:nvPr/>
-        </p:nvSpPr>
-        <p:spPr>
-          <a:xfrm>
-            <a:off x="8321040" y="3429000"/>
-            <a:ext cx="5394960" cy="228600"/>
-          </a:xfrm>
-          <a:prstGeom prst="rect">
-            <a:avLst/>
-          </a:prstGeom>
-          <a:noFill/>
-        </p:spPr>
-        <p:txBody>
-          <a:bodyPr wrap="square">
-            <a:spAutoFit/>
-          </a:bodyPr>
-          <a:lstStyle/>
-          <a:p>
-            <a:pPr algn="l">
-              <a:spcAft>
-                <a:spcPts val="0"/>
-              </a:spcAft>
-              <a:defRPr sz="750" b="0">
-                <a:solidFill>
-                  <a:srgbClr val="666666"/>
-                </a:solidFill>
-                <a:latin typeface="Arial"/>
-              </a:defRPr>
-            </a:pPr>
-            <a:r>
-              <a:t>Human-in-the-Loop: Jede kundenseitige Aktion (E-Mail, Nachricht, Anruf) erfordert explizite Freigabe durch den Kundenberater.</a:t>
-            </a:r>
-          </a:p>
-        </p:txBody>
-      </p:sp>
-      <p:sp>
-        <p:nvSpPr>
-          <p:cNvPr id="49" name="TextBox 48"/>
-          <p:cNvSpPr txBox="1"/>
-          <p:nvPr/>
-        </p:nvSpPr>
-        <p:spPr>
-          <a:xfrm>
-            <a:off x="7955279" y="3703320"/>
-            <a:ext cx="5760720" cy="182880"/>
-          </a:xfrm>
-          <a:prstGeom prst="rect">
-            <a:avLst/>
-          </a:prstGeom>
-          <a:noFill/>
-        </p:spPr>
-        <p:txBody>
-          <a:bodyPr wrap="square">
-            <a:spAutoFit/>
-          </a:bodyPr>
-          <a:lstStyle/>
-          <a:p>
-            <a:pPr algn="l">
-              <a:spcAft>
-                <a:spcPts val="0"/>
-              </a:spcAft>
-              <a:defRPr sz="900" b="1">
-                <a:solidFill>
-                  <a:srgbClr val="16803C"/>
-                </a:solidFill>
-                <a:latin typeface="Arial"/>
-              </a:defRPr>
-            </a:pPr>
-            <a:r>
-              <a:t>✓  Volle Nachvollziehbarkeit</a:t>
-            </a:r>
-          </a:p>
-        </p:txBody>
-      </p:sp>
-      <p:sp>
-        <p:nvSpPr>
-          <p:cNvPr id="50" name="TextBox 49"/>
-          <p:cNvSpPr txBox="1"/>
-          <p:nvPr/>
-        </p:nvSpPr>
-        <p:spPr>
-          <a:xfrm>
-            <a:off x="8321040" y="3886200"/>
-            <a:ext cx="5394960" cy="228600"/>
-          </a:xfrm>
-          <a:prstGeom prst="rect">
-            <a:avLst/>
-          </a:prstGeom>
-          <a:noFill/>
-        </p:spPr>
-        <p:txBody>
-          <a:bodyPr wrap="square">
-            <a:spAutoFit/>
-          </a:bodyPr>
-          <a:lstStyle/>
-          <a:p>
-            <a:pPr algn="l">
-              <a:spcAft>
-                <a:spcPts val="0"/>
-              </a:spcAft>
-              <a:defRPr sz="750" b="0">
-                <a:solidFill>
-                  <a:srgbClr val="666666"/>
-                </a:solidFill>
-                <a:latin typeface="Arial"/>
-              </a:defRPr>
-            </a:pPr>
-            <a:r>
-              <a:t>Jede AI-Aktion wird protokolliert — Tool-Aufrufe, Eingaben, Ergebnisse. Vollständiger Audit-Trail für regulatorische Prüfungen.</a:t>
-            </a:r>
-          </a:p>
-        </p:txBody>
-      </p:sp>
-      <p:sp>
-        <p:nvSpPr>
-          <p:cNvPr id="51" name="TextBox 50"/>
-          <p:cNvSpPr txBox="1"/>
-          <p:nvPr/>
-        </p:nvSpPr>
-        <p:spPr>
-          <a:xfrm>
-            <a:off x="7955279" y="4160520"/>
-            <a:ext cx="5760720" cy="182880"/>
-          </a:xfrm>
-          <a:prstGeom prst="rect">
-            <a:avLst/>
-          </a:prstGeom>
-          <a:noFill/>
-        </p:spPr>
-        <p:txBody>
-          <a:bodyPr wrap="square">
-            <a:spAutoFit/>
-          </a:bodyPr>
-          <a:lstStyle/>
-          <a:p>
-            <a:pPr algn="l">
-              <a:spcAft>
-                <a:spcPts val="0"/>
-              </a:spcAft>
-              <a:defRPr sz="900" b="1">
-                <a:solidFill>
-                  <a:srgbClr val="16803C"/>
-                </a:solidFill>
-                <a:latin typeface="Arial"/>
-              </a:defRPr>
-            </a:pPr>
-            <a:r>
-              <a:t>✓  Mandantenfähig</a:t>
-            </a:r>
-          </a:p>
-        </p:txBody>
-      </p:sp>
-      <p:sp>
-        <p:nvSpPr>
-          <p:cNvPr id="52" name="TextBox 51"/>
-          <p:cNvSpPr txBox="1"/>
-          <p:nvPr/>
-        </p:nvSpPr>
-        <p:spPr>
-          <a:xfrm>
-            <a:off x="8321040" y="4343400"/>
-            <a:ext cx="5394960" cy="228600"/>
-          </a:xfrm>
-          <a:prstGeom prst="rect">
-            <a:avLst/>
-          </a:prstGeom>
-          <a:noFill/>
-        </p:spPr>
-        <p:txBody>
-          <a:bodyPr wrap="square">
-            <a:spAutoFit/>
-          </a:bodyPr>
-          <a:lstStyle/>
-          <a:p>
-            <a:pPr algn="l">
-              <a:spcAft>
-                <a:spcPts val="0"/>
-              </a:spcAft>
-              <a:defRPr sz="750" b="0">
-                <a:solidFill>
-                  <a:srgbClr val="666666"/>
-                </a:solidFill>
-                <a:latin typeface="Arial"/>
-              </a:defRPr>
-            </a:pPr>
-            <a:r>
-              <a:t>Jede Genossenschaftsbank erhält einen isolierten Mandanten. Datentrennung auf Datenbankebene (PostgreSQL Row Level Security).</a:t>
-            </a:r>
-          </a:p>
-        </p:txBody>
-      </p:sp>
-      <p:sp>
-        <p:nvSpPr>
-          <p:cNvPr id="53" name="TextBox 52"/>
-          <p:cNvSpPr txBox="1"/>
-          <p:nvPr/>
-        </p:nvSpPr>
-        <p:spPr>
-          <a:xfrm>
-            <a:off x="7772400" y="4846320"/>
-            <a:ext cx="4572000" cy="182880"/>
-          </a:xfrm>
-          <a:prstGeom prst="rect">
-            <a:avLst/>
-          </a:prstGeom>
-          <a:noFill/>
-        </p:spPr>
-        <p:txBody>
-          <a:bodyPr wrap="square">
-            <a:spAutoFit/>
-          </a:bodyPr>
-          <a:lstStyle/>
-          <a:p>
-            <a:pPr algn="l">
-              <a:spcAft>
-                <a:spcPts val="0"/>
-              </a:spcAft>
-              <a:defRPr sz="900" b="1">
-                <a:solidFill>
-                  <a:srgbClr val="003366"/>
-                </a:solidFill>
-                <a:latin typeface="Arial"/>
-              </a:defRPr>
-            </a:pPr>
-            <a:r>
-              <a:t>ÜBER DEN PARTNER</a:t>
-            </a:r>
-          </a:p>
-        </p:txBody>
-      </p:sp>
-      <p:sp>
-        <p:nvSpPr>
-          <p:cNvPr id="54" name="Rounded Rectangle 53"/>
-          <p:cNvSpPr/>
-          <p:nvPr/>
-        </p:nvSpPr>
-        <p:spPr>
-          <a:xfrm>
-            <a:off x="7772400" y="5074920"/>
-            <a:ext cx="6126480" cy="1463040"/>
-          </a:xfrm>
-          <a:prstGeom prst="roundRect">
-            <a:avLst>
-              <a:gd name="adj" fmla="val 3000"/>
-            </a:avLst>
-          </a:prstGeom>
-          <a:solidFill>
-            <a:srgbClr val="F7F7F7"/>
-          </a:solidFill>
-          <a:ln>
-            <a:noFill/>
-          </a:ln>
-        </p:spPr>
-        <p:style>
-          <a:lnRef idx="1">
-            <a:schemeClr val="accent1"/>
-          </a:lnRef>
-          <a:fillRef idx="3">
-            <a:schemeClr val="accent1"/>
-          </a:fillRef>
-          <a:effectRef idx="2">
-            <a:schemeClr val="accent1"/>
-          </a:effectRef>
-          <a:fontRef idx="minor">
-            <a:schemeClr val="lt1"/>
-          </a:fontRef>
-        </p:style>
-        <p:txBody>
-          <a:bodyPr rtlCol="0" anchor="ctr"/>
-          <a:lstStyle/>
-          <a:p>
-            <a:pPr algn="ctr"/>
-          </a:p>
-        </p:txBody>
-      </p:sp>
-      <p:sp>
-        <p:nvSpPr>
-          <p:cNvPr id="55" name="TextBox 54"/>
-          <p:cNvSpPr txBox="1"/>
-          <p:nvPr/>
-        </p:nvSpPr>
-        <p:spPr>
-          <a:xfrm>
-            <a:off x="7955279" y="5120640"/>
-            <a:ext cx="5760720" cy="1371600"/>
-          </a:xfrm>
-          <a:prstGeom prst="rect">
-            <a:avLst/>
-          </a:prstGeom>
-          <a:noFill/>
-        </p:spPr>
-        <p:txBody>
-          <a:bodyPr wrap="square">
-            <a:spAutoFit/>
-          </a:bodyPr>
-          <a:lstStyle/>
-          <a:p>
-            <a:pPr algn="l">
-              <a:lnSpc>
-                <a:spcPts val="1400"/>
-              </a:lnSpc>
-              <a:spcAft>
-                <a:spcPts val="200"/>
-              </a:spcAft>
-              <a:defRPr sz="1000" b="1">
-                <a:solidFill>
-                  <a:srgbClr val="1A1A1A"/>
-                </a:solidFill>
-                <a:latin typeface="Arial"/>
-              </a:defRPr>
-            </a:pPr>
-            <a:r>
-              <a:t>Salesteq (Elyon GmbH, Zug)</a:t>
-            </a:r>
-          </a:p>
-          <a:p>
-            <a:pPr algn="l">
-              <a:lnSpc>
-                <a:spcPts val="1189"/>
-              </a:lnSpc>
-              <a:spcAft>
-                <a:spcPts val="200"/>
-              </a:spcAft>
-              <a:defRPr sz="850" b="0">
-                <a:solidFill>
-                  <a:srgbClr val="666666"/>
-                </a:solidFill>
-                <a:latin typeface="Arial"/>
-              </a:defRPr>
-            </a:pPr>
-            <a:r>
-              <a:t>Plattform für autonome kommerzielle AI-Agenten (Vertrieb, Marketing, Kundenservice).</a:t>
-            </a:r>
-          </a:p>
-          <a:p>
-            <a:pPr algn="l">
-              <a:lnSpc>
-                <a:spcPts val="700"/>
-              </a:lnSpc>
-              <a:spcAft>
-                <a:spcPts val="200"/>
-              </a:spcAft>
-              <a:defRPr sz="500" b="0">
-                <a:solidFill>
-                  <a:srgbClr val="666666"/>
-                </a:solidFill>
-                <a:latin typeface="Arial"/>
-              </a:defRPr>
-            </a:pPr>
-          </a:p>
-          <a:p>
-            <a:pPr algn="l">
-              <a:lnSpc>
-                <a:spcPts val="1189"/>
-              </a:lnSpc>
-              <a:spcAft>
-                <a:spcPts val="200"/>
-              </a:spcAft>
-              <a:defRPr sz="850" b="1">
-                <a:solidFill>
-                  <a:srgbClr val="1A1A1A"/>
-                </a:solidFill>
-                <a:latin typeface="Arial"/>
-              </a:defRPr>
-            </a:pPr>
-            <a:r>
-              <a:t>Referenzen:</a:t>
-            </a:r>
-          </a:p>
-          <a:p>
-            <a:pPr algn="l">
-              <a:lnSpc>
-                <a:spcPts val="1189"/>
-              </a:lnSpc>
-              <a:spcAft>
-                <a:spcPts val="200"/>
-              </a:spcAft>
-              <a:defRPr sz="850" b="0">
-                <a:solidFill>
-                  <a:srgbClr val="666666"/>
-                </a:solidFill>
-                <a:latin typeface="Arial"/>
-              </a:defRPr>
-            </a:pPr>
-            <a:r>
-              <a:t>·  Naghi Group / BMW Saudi-Arabien — Produktion, Voice AI in Arabisch, 15'000+ MA</a:t>
-            </a:r>
-          </a:p>
-          <a:p>
-            <a:pPr algn="l">
-              <a:lnSpc>
-                <a:spcPts val="1189"/>
-              </a:lnSpc>
-              <a:spcAft>
-                <a:spcPts val="200"/>
-              </a:spcAft>
-              <a:defRPr sz="850" b="0">
-                <a:solidFill>
-                  <a:srgbClr val="666666"/>
-                </a:solidFill>
-                <a:latin typeface="Arial"/>
-              </a:defRPr>
-            </a:pPr>
-            <a:r>
-              <a:t>·  Suhner Abrasive (CH) — AI-Verkaufsassistent, 4 Sprachen, 737 Produkte</a:t>
-            </a:r>
-          </a:p>
-          <a:p>
-            <a:pPr algn="l">
-              <a:lnSpc>
-                <a:spcPts val="1189"/>
-              </a:lnSpc>
-              <a:spcAft>
-                <a:spcPts val="200"/>
-              </a:spcAft>
-              <a:defRPr sz="850" b="0">
-                <a:solidFill>
-                  <a:srgbClr val="666666"/>
-                </a:solidFill>
-                <a:latin typeface="Arial"/>
-              </a:defRPr>
-            </a:pPr>
-            <a:r>
-              <a:t>·  Allianz Suisse — Pilot, AI in der Kundenforschung (Test &amp; Learn)</a:t>
-            </a:r>
-          </a:p>
-          <a:p>
-            <a:pPr algn="l">
-              <a:lnSpc>
-                <a:spcPts val="700"/>
-              </a:lnSpc>
-              <a:spcAft>
-                <a:spcPts val="200"/>
-              </a:spcAft>
-              <a:defRPr sz="500" b="0">
-                <a:solidFill>
-                  <a:srgbClr val="666666"/>
-                </a:solidFill>
-                <a:latin typeface="Arial"/>
-              </a:defRPr>
-            </a:pPr>
-          </a:p>
-          <a:p>
-            <a:pPr algn="l">
-              <a:lnSpc>
-                <a:spcPts val="1189"/>
-              </a:lnSpc>
-              <a:spcAft>
-                <a:spcPts val="200"/>
-              </a:spcAft>
-              <a:defRPr sz="850" b="0">
-                <a:solidFill>
-                  <a:srgbClr val="666666"/>
-                </a:solidFill>
-                <a:latin typeface="Arial"/>
-              </a:defRPr>
-            </a:pPr>
-            <a:r>
-              <a:t>NVIDIA Inception Program Member. Eigene Sprach-Engine (nicht API-Wrapper).</a:t>
-            </a:r>
-          </a:p>
-        </p:txBody>
-      </p:sp>
-      <p:sp>
-        <p:nvSpPr>
-          <p:cNvPr id="56" name="Rounded Rectangle 55"/>
-          <p:cNvSpPr/>
-          <p:nvPr/>
-        </p:nvSpPr>
-        <p:spPr>
-          <a:xfrm>
-            <a:off x="731520" y="7360920"/>
-            <a:ext cx="13167360" cy="640080"/>
-          </a:xfrm>
-          <a:prstGeom prst="roundRect">
-            <a:avLst>
-              <a:gd name="adj" fmla="val 3000"/>
-            </a:avLst>
-          </a:prstGeom>
-          <a:solidFill>
-            <a:srgbClr val="003366"/>
-          </a:solidFill>
-          <a:ln>
-            <a:noFill/>
-          </a:ln>
-        </p:spPr>
-        <p:style>
-          <a:lnRef idx="1">
-            <a:schemeClr val="accent1"/>
-          </a:lnRef>
-          <a:fillRef idx="3">
-            <a:schemeClr val="accent1"/>
-          </a:fillRef>
-          <a:effectRef idx="2">
-            <a:schemeClr val="accent1"/>
-          </a:effectRef>
-          <a:fontRef idx="minor">
-            <a:schemeClr val="lt1"/>
-          </a:fontRef>
-        </p:style>
-        <p:txBody>
-          <a:bodyPr rtlCol="0" anchor="ctr"/>
-          <a:lstStyle/>
-          <a:p>
-            <a:pPr algn="ctr"/>
-          </a:p>
-        </p:txBody>
-      </p:sp>
-      <p:sp>
-        <p:nvSpPr>
-          <p:cNvPr id="57" name="TextBox 56"/>
-          <p:cNvSpPr txBox="1"/>
-          <p:nvPr/>
-        </p:nvSpPr>
-        <p:spPr>
-          <a:xfrm>
-            <a:off x="1005840" y="7406640"/>
-            <a:ext cx="2743200" cy="228600"/>
-          </a:xfrm>
-          <a:prstGeom prst="rect">
-            <a:avLst/>
-          </a:prstGeom>
-          <a:noFill/>
-        </p:spPr>
-        <p:txBody>
-          <a:bodyPr wrap="square">
-            <a:spAutoFit/>
-          </a:bodyPr>
-          <a:lstStyle/>
-          <a:p>
-            <a:pPr algn="l">
-              <a:spcAft>
-                <a:spcPts val="0"/>
-              </a:spcAft>
-              <a:defRPr sz="800" b="1">
+              <a:defRPr sz="900" b="0">
                 <a:solidFill>
                   <a:srgbClr val="88AACC"/>
                 </a:solidFill>
@@ -5702,89 +5645,7 @@
               </a:defRPr>
             </a:pPr>
             <a:r>
-              <a:t>EMPFOHLENER NÄCHSTER SCHRITT</a:t>
-            </a:r>
-          </a:p>
-        </p:txBody>
-      </p:sp>
-      <p:sp>
-        <p:nvSpPr>
-          <p:cNvPr id="58" name="TextBox 57"/>
-          <p:cNvSpPr txBox="1"/>
-          <p:nvPr/>
-        </p:nvSpPr>
-        <p:spPr>
-          <a:xfrm>
-            <a:off x="1005840" y="7635240"/>
-            <a:ext cx="9144000" cy="274320"/>
-          </a:xfrm>
-          <a:prstGeom prst="rect">
-            <a:avLst/>
-          </a:prstGeom>
-          <a:noFill/>
-        </p:spPr>
-        <p:txBody>
-          <a:bodyPr wrap="square">
-            <a:spAutoFit/>
-          </a:bodyPr>
-          <a:lstStyle/>
-          <a:p>
-            <a:pPr algn="l">
-              <a:spcAft>
-                <a:spcPts val="0"/>
-              </a:spcAft>
-              <a:defRPr sz="1200" b="1">
-                <a:solidFill>
-                  <a:srgbClr val="FFFFFF"/>
-                </a:solidFill>
-                <a:latin typeface="Arial"/>
-              </a:defRPr>
-            </a:pPr>
-            <a:r>
-              <a:t>90-Minuten-Gespräch mit einem Kundenberater Ihrer Wahl. Wir hören zu. Kein Vertrag, keine Kosten.</a:t>
-            </a:r>
-          </a:p>
-        </p:txBody>
-      </p:sp>
-      <p:sp>
-        <p:nvSpPr>
-          <p:cNvPr id="59" name="TextBox 58"/>
-          <p:cNvSpPr txBox="1"/>
-          <p:nvPr/>
-        </p:nvSpPr>
-        <p:spPr>
-          <a:xfrm>
-            <a:off x="10515600" y="7498079"/>
-            <a:ext cx="3383280" cy="411480"/>
-          </a:xfrm>
-          <a:prstGeom prst="rect">
-            <a:avLst/>
-          </a:prstGeom>
-          <a:noFill/>
-        </p:spPr>
-        <p:txBody>
-          <a:bodyPr wrap="square">
-            <a:spAutoFit/>
-          </a:bodyPr>
-          <a:lstStyle/>
-          <a:p>
-            <a:pPr algn="r">
-              <a:spcAft>
-                <a:spcPts val="0"/>
-              </a:spcAft>
-              <a:defRPr sz="900" b="0">
-                <a:solidFill>
-                  <a:srgbClr val="88AACC"/>
-                </a:solidFill>
-                <a:latin typeface="Arial"/>
-              </a:defRPr>
-            </a:pPr>
-            <a:r>
-              <a:t>Kontakt: Viktor Andreas</a:t>
-            </a:r>
-            <a:br/>
-            <a:r>
-              <a:t>viktor@salesteq.com</a:t>
+              <a:t>Viktor Andreas · viktor@salesteq.com</a:t>
             </a:r>
           </a:p>
         </p:txBody>

</xml_diff>

<commit_message>
update: Raiffeisen assets — joint discovery framing
Co-Authored-By: Claude Opus 4.6 (1M context) <noreply@anthropic.com>
</commit_message>
<xml_diff>
--- a/Raiffeisen-Entscheidungsvorlage.pptx
+++ b/Raiffeisen-Entscheidungsvorlage.pptx
@@ -3173,7 +3173,7 @@
               </a:defRPr>
             </a:pPr>
             <a:r>
-              <a:t>AI Test &amp; Learn im Vertrieb — Pilotvorschlag</a:t>
+              <a:t>AI im Vertrieb — Gemeinsame Erkundung</a:t>
             </a:r>
           </a:p>
         </p:txBody>
@@ -3290,7 +3290,7 @@
               </a:defRPr>
             </a:pPr>
             <a:r>
-              <a:t>AI-Pilotprojekt Vertrieb</a:t>
+              <a:t>AI-Potenzial im Vertrieb erkunden</a:t>
             </a:r>
           </a:p>
         </p:txBody>
@@ -3726,7 +3726,7 @@
               </a:defRPr>
             </a:pPr>
             <a:r>
-              <a:t>Raiffeisen setzt bereits AI ein (Meeting-Vorbereitung, Chatbot Tina). Für die nächste</a:t>
+              <a:t>Raiffeisen setzt bereits AI ein (Meeting-Vorbereitung, Chatbot Tina). Die Frage</a:t>
             </a:r>
           </a:p>
           <a:p>
@@ -3745,7 +3745,7 @@
               </a:defRPr>
             </a:pPr>
             <a:r>
-              <a:t>Stufe — proaktive Kundenansprache, Berater-Training, Cross-Selling-Intelligenz —</a:t>
+              <a:t>ist nicht ob, sondern wo AI im Vertrieb den grössten Hebel hat. Im März 2026</a:t>
             </a:r>
           </a:p>
           <a:p>
@@ -3764,7 +3764,7 @@
               </a:defRPr>
             </a:pPr>
             <a:r>
-              <a:t>fehlt ein Partner mit Produktionserfahrung. Im März 2026 wurde vereinbart, einen</a:t>
+              <a:t>wurde vereinbart, das gemeinsam zu erkunden — mit einem externen Partner, der</a:t>
             </a:r>
           </a:p>
           <a:p>
@@ -3783,7 +3783,7 @@
               </a:defRPr>
             </a:pPr>
             <a:r>
-              <a:t>leichtgewichtigen Pilotvorschlag zu erarbeiten, analog Allianz Suisse.</a:t>
+              <a:t>Produktionserfahrung mitbringt. Analog zum Vorgehen mit Allianz Suisse.</a:t>
             </a:r>
           </a:p>
         </p:txBody>
@@ -3904,7 +3904,7 @@
               </a:defRPr>
             </a:pPr>
             <a:r>
-              <a:t>Ein begrenzter Test-and-Learn-Pilot in 3 Schritten:</a:t>
+              <a:t>Vorgehen:</a:t>
             </a:r>
           </a:p>
         </p:txBody>
@@ -3982,7 +3982,7 @@
               </a:defRPr>
             </a:pPr>
             <a:r>
-              <a:t>Workshop (½ Tag)</a:t>
+              <a:t>Discovery (½ Tag)</a:t>
             </a:r>
           </a:p>
         </p:txBody>
@@ -4021,7 +4021,7 @@
               </a:defRPr>
             </a:pPr>
             <a:r>
-              <a:t>Use Cases gemeinsam identifizieren und priorisieren</a:t>
+              <a:t>Vertriebsprozess gemeinsam analysieren → Handlungsempfehlung erarbeiten</a:t>
             </a:r>
           </a:p>
         </p:txBody>
@@ -4099,7 +4099,7 @@
               </a:defRPr>
             </a:pPr>
             <a:r>
-              <a:t>Prototyp (6 Wochen)</a:t>
+              <a:t>Handlungsempfehlung</a:t>
             </a:r>
           </a:p>
         </p:txBody>
@@ -4138,7 +4138,7 @@
               </a:defRPr>
             </a:pPr>
             <a:r>
-              <a:t>Einen Use Case für eine Raiffeisenbank umsetzen</a:t>
+              <a:t>Ivo erhält ein Dokument, das er intern mit IT und Stakeholdern testen kann</a:t>
             </a:r>
           </a:p>
         </p:txBody>
@@ -4216,7 +4216,7 @@
               </a:defRPr>
             </a:pPr>
             <a:r>
-              <a:t>Bewertung</a:t>
+              <a:t>Entscheiden</a:t>
             </a:r>
           </a:p>
         </p:txBody>
@@ -4255,7 +4255,7 @@
               </a:defRPr>
             </a:pPr>
             <a:r>
-              <a:t>Ergebnisse messen, Feedback einholen, über nächste Schritte entscheiden</a:t>
+              <a:t>Auf Basis der Empfehlung: nächste Schritte gemeinsam festlegen</a:t>
             </a:r>
           </a:p>
         </p:txBody>
@@ -4337,7 +4337,7 @@
               </a:defRPr>
             </a:pPr>
             <a:r>
-              <a:t>MÖGLICHE USE CASES</a:t>
+              <a:t>IDEENBACKLOG (ZUR DISKUSSION)</a:t>
             </a:r>
           </a:p>
         </p:txBody>
@@ -4351,7 +4351,7 @@
         <p:spPr>
           <a:xfrm>
             <a:off x="731520" y="5532120"/>
-            <a:ext cx="274320" cy="274320"/>
+            <a:ext cx="182880" cy="274320"/>
           </a:xfrm>
           <a:prstGeom prst="rect">
             <a:avLst/>
@@ -4376,7 +4376,7 @@
               </a:defRPr>
             </a:pPr>
             <a:r>
-              <a:t>A</a:t>
+              <a:t>·</a:t>
             </a:r>
           </a:p>
         </p:txBody>
@@ -4389,7 +4389,7 @@
         </p:nvSpPr>
         <p:spPr>
           <a:xfrm>
-            <a:off x="1051560" y="5532120"/>
+            <a:off x="960120" y="5532120"/>
             <a:ext cx="2560320" cy="274320"/>
           </a:xfrm>
           <a:prstGeom prst="rect">
@@ -4415,7 +4415,7 @@
               </a:defRPr>
             </a:pPr>
             <a:r>
-              <a:t>Berater-Training &amp; Onboarding</a:t>
+              <a:t>RM-Training &amp; Onboarding</a:t>
             </a:r>
           </a:p>
         </p:txBody>
@@ -4428,8 +4428,8 @@
         </p:nvSpPr>
         <p:spPr>
           <a:xfrm>
-            <a:off x="3749039" y="5532120"/>
-            <a:ext cx="4754880" cy="274320"/>
+            <a:off x="3657600" y="5532120"/>
+            <a:ext cx="4846320" cy="274320"/>
           </a:xfrm>
           <a:prstGeom prst="rect">
             <a:avLst/>
@@ -4454,7 +4454,7 @@
               </a:defRPr>
             </a:pPr>
             <a:r>
-              <a:t>AI als Sparringspartner für neue und erfahrene RMs</a:t>
+              <a:t>Sparringspartner für neue und erfahrene Berater</a:t>
             </a:r>
           </a:p>
         </p:txBody>
@@ -4467,8 +4467,8 @@
         </p:nvSpPr>
         <p:spPr>
           <a:xfrm>
-            <a:off x="731520" y="5989320"/>
-            <a:ext cx="274320" cy="274320"/>
+            <a:off x="731520" y="5916168"/>
+            <a:ext cx="182880" cy="274320"/>
           </a:xfrm>
           <a:prstGeom prst="rect">
             <a:avLst/>
@@ -4493,7 +4493,7 @@
               </a:defRPr>
             </a:pPr>
             <a:r>
-              <a:t>B</a:t>
+              <a:t>·</a:t>
             </a:r>
           </a:p>
         </p:txBody>
@@ -4506,7 +4506,7 @@
         </p:nvSpPr>
         <p:spPr>
           <a:xfrm>
-            <a:off x="1051560" y="5989320"/>
+            <a:off x="960120" y="5916168"/>
             <a:ext cx="2560320" cy="274320"/>
           </a:xfrm>
           <a:prstGeom prst="rect">
@@ -4532,7 +4532,7 @@
               </a:defRPr>
             </a:pPr>
             <a:r>
-              <a:t>Proaktive Kundenansprache</a:t>
+              <a:t>Produktwissen für 212 Banken</a:t>
             </a:r>
           </a:p>
         </p:txBody>
@@ -4545,8 +4545,8 @@
         </p:nvSpPr>
         <p:spPr>
           <a:xfrm>
-            <a:off x="3749039" y="5989320"/>
-            <a:ext cx="4754880" cy="274320"/>
+            <a:off x="3657600" y="5916168"/>
+            <a:ext cx="4846320" cy="274320"/>
           </a:xfrm>
           <a:prstGeom prst="rect">
             <a:avLst/>
@@ -4571,7 +4571,7 @@
               </a:defRPr>
             </a:pPr>
             <a:r>
-              <a:t>Trigger-basiert bei Zinsänderungen, Festhypothek-Ablauf, Lebensereignissen</a:t>
+              <a:t>Einheitliche Wissensbasis, immer aktuell, drei Sprachen</a:t>
             </a:r>
           </a:p>
         </p:txBody>
@@ -4584,8 +4584,8 @@
         </p:nvSpPr>
         <p:spPr>
           <a:xfrm>
-            <a:off x="731520" y="6446520"/>
-            <a:ext cx="274320" cy="274320"/>
+            <a:off x="731520" y="6300216"/>
+            <a:ext cx="182880" cy="274320"/>
           </a:xfrm>
           <a:prstGeom prst="rect">
             <a:avLst/>
@@ -4610,7 +4610,7 @@
               </a:defRPr>
             </a:pPr>
             <a:r>
-              <a:t>C</a:t>
+              <a:t>·</a:t>
             </a:r>
           </a:p>
         </p:txBody>
@@ -4623,7 +4623,7 @@
         </p:nvSpPr>
         <p:spPr>
           <a:xfrm>
-            <a:off x="1051560" y="6446520"/>
+            <a:off x="960120" y="6300216"/>
             <a:ext cx="2560320" cy="274320"/>
           </a:xfrm>
           <a:prstGeom prst="rect">
@@ -4649,7 +4649,7 @@
               </a:defRPr>
             </a:pPr>
             <a:r>
-              <a:t>Produktwissen für 212 Banken</a:t>
+              <a:t>Erster Kundenkontakt</a:t>
             </a:r>
           </a:p>
         </p:txBody>
@@ -4662,8 +4662,8 @@
         </p:nvSpPr>
         <p:spPr>
           <a:xfrm>
-            <a:off x="3749039" y="6446520"/>
-            <a:ext cx="4754880" cy="274320"/>
+            <a:off x="3657600" y="6300216"/>
+            <a:ext cx="4846320" cy="274320"/>
           </a:xfrm>
           <a:prstGeom prst="rect">
             <a:avLst/>
@@ -4688,7 +4688,7 @@
               </a:defRPr>
             </a:pPr>
             <a:r>
-              <a:t>Einheitliche AI-Wissensbasis, immer aktuell, drei Sprachen</a:t>
+              <a:t>Chat und Telefon in DE/FR/IT, qualifizierte Weiterleitung</a:t>
             </a:r>
           </a:p>
         </p:txBody>
@@ -4701,8 +4701,8 @@
         </p:nvSpPr>
         <p:spPr>
           <a:xfrm>
-            <a:off x="731520" y="6903720"/>
-            <a:ext cx="274320" cy="274320"/>
+            <a:off x="731520" y="6684264"/>
+            <a:ext cx="182880" cy="274320"/>
           </a:xfrm>
           <a:prstGeom prst="rect">
             <a:avLst/>
@@ -4727,7 +4727,7 @@
               </a:defRPr>
             </a:pPr>
             <a:r>
-              <a:t>D</a:t>
+              <a:t>·</a:t>
             </a:r>
           </a:p>
         </p:txBody>
@@ -4740,7 +4740,7 @@
         </p:nvSpPr>
         <p:spPr>
           <a:xfrm>
-            <a:off x="1051560" y="6903720"/>
+            <a:off x="960120" y="6684264"/>
             <a:ext cx="2560320" cy="274320"/>
           </a:xfrm>
           <a:prstGeom prst="rect">
@@ -4766,7 +4766,7 @@
               </a:defRPr>
             </a:pPr>
             <a:r>
-              <a:t>Erster Kundenkontakt</a:t>
+              <a:t>Cross-Selling-Signale</a:t>
             </a:r>
           </a:p>
         </p:txBody>
@@ -4779,8 +4779,8 @@
         </p:nvSpPr>
         <p:spPr>
           <a:xfrm>
-            <a:off x="3749039" y="6903720"/>
-            <a:ext cx="4754880" cy="274320"/>
+            <a:off x="3657600" y="6684264"/>
+            <a:ext cx="4846320" cy="274320"/>
           </a:xfrm>
           <a:prstGeom prst="rect">
             <a:avLst/>
@@ -4805,14 +4805,131 @@
               </a:defRPr>
             </a:pPr>
             <a:r>
-              <a:t>Chat und Telefon in DE/FR/IT, qualifizierte Weiterleitung an Berater</a:t>
-            </a:r>
-          </a:p>
-        </p:txBody>
-      </p:sp>
-      <p:sp>
-        <p:nvSpPr>
-          <p:cNvPr id="44" name="Rectangle 43"/>
+              <a:t>Portfolio-Lücken erkennen und Kontaktanlässe priorisieren</a:t>
+            </a:r>
+          </a:p>
+        </p:txBody>
+      </p:sp>
+      <p:sp>
+        <p:nvSpPr>
+          <p:cNvPr id="44" name="TextBox 43"/>
+          <p:cNvSpPr txBox="1"/>
+          <p:nvPr/>
+        </p:nvSpPr>
+        <p:spPr>
+          <a:xfrm>
+            <a:off x="731520" y="7068312"/>
+            <a:ext cx="182880" cy="274320"/>
+          </a:xfrm>
+          <a:prstGeom prst="rect">
+            <a:avLst/>
+          </a:prstGeom>
+          <a:noFill/>
+        </p:spPr>
+        <p:txBody>
+          <a:bodyPr wrap="square">
+            <a:spAutoFit/>
+          </a:bodyPr>
+          <a:lstStyle/>
+          <a:p>
+            <a:pPr algn="l">
+              <a:spcAft>
+                <a:spcPts val="0"/>
+              </a:spcAft>
+              <a:defRPr sz="1100" b="1">
+                <a:solidFill>
+                  <a:srgbClr val="003366"/>
+                </a:solidFill>
+                <a:latin typeface="Arial"/>
+              </a:defRPr>
+            </a:pPr>
+            <a:r>
+              <a:t>·</a:t>
+            </a:r>
+          </a:p>
+        </p:txBody>
+      </p:sp>
+      <p:sp>
+        <p:nvSpPr>
+          <p:cNvPr id="45" name="TextBox 44"/>
+          <p:cNvSpPr txBox="1"/>
+          <p:nvPr/>
+        </p:nvSpPr>
+        <p:spPr>
+          <a:xfrm>
+            <a:off x="960120" y="7068312"/>
+            <a:ext cx="2560320" cy="274320"/>
+          </a:xfrm>
+          <a:prstGeom prst="rect">
+            <a:avLst/>
+          </a:prstGeom>
+          <a:noFill/>
+        </p:spPr>
+        <p:txBody>
+          <a:bodyPr wrap="square">
+            <a:spAutoFit/>
+          </a:bodyPr>
+          <a:lstStyle/>
+          <a:p>
+            <a:pPr algn="l">
+              <a:spcAft>
+                <a:spcPts val="0"/>
+              </a:spcAft>
+              <a:defRPr sz="1000" b="1">
+                <a:solidFill>
+                  <a:srgbClr val="1A1A1A"/>
+                </a:solidFill>
+                <a:latin typeface="Arial"/>
+              </a:defRPr>
+            </a:pPr>
+            <a:r>
+              <a:t>Kampagnen-Unterstützung</a:t>
+            </a:r>
+          </a:p>
+        </p:txBody>
+      </p:sp>
+      <p:sp>
+        <p:nvSpPr>
+          <p:cNvPr id="46" name="TextBox 45"/>
+          <p:cNvSpPr txBox="1"/>
+          <p:nvPr/>
+        </p:nvSpPr>
+        <p:spPr>
+          <a:xfrm>
+            <a:off x="3657600" y="7068312"/>
+            <a:ext cx="4846320" cy="274320"/>
+          </a:xfrm>
+          <a:prstGeom prst="rect">
+            <a:avLst/>
+          </a:prstGeom>
+          <a:noFill/>
+        </p:spPr>
+        <p:txBody>
+          <a:bodyPr wrap="square">
+            <a:spAutoFit/>
+          </a:bodyPr>
+          <a:lstStyle/>
+          <a:p>
+            <a:pPr algn="l">
+              <a:spcAft>
+                <a:spcPts val="0"/>
+              </a:spcAft>
+              <a:defRPr sz="1000" b="0">
+                <a:solidFill>
+                  <a:srgbClr val="777777"/>
+                </a:solidFill>
+                <a:latin typeface="Arial"/>
+              </a:defRPr>
+            </a:pPr>
+            <a:r>
+              <a:t>Personalisierte Ansprache, vom RM freigegeben</a:t>
+            </a:r>
+          </a:p>
+        </p:txBody>
+      </p:sp>
+      <p:sp>
+        <p:nvSpPr>
+          <p:cNvPr id="47" name="Rectangle 46"/>
           <p:cNvSpPr/>
           <p:nvPr/>
         </p:nvSpPr>
@@ -4855,7 +4972,7 @@
       </p:sp>
       <p:sp>
         <p:nvSpPr>
-          <p:cNvPr id="45" name="TextBox 44"/>
+          <p:cNvPr id="48" name="TextBox 47"/>
           <p:cNvSpPr txBox="1"/>
           <p:nvPr/>
         </p:nvSpPr>
@@ -4894,7 +5011,7 @@
       </p:sp>
       <p:sp>
         <p:nvSpPr>
-          <p:cNvPr id="46" name="TextBox 45"/>
+          <p:cNvPr id="49" name="TextBox 48"/>
           <p:cNvSpPr txBox="1"/>
           <p:nvPr/>
         </p:nvSpPr>
@@ -4933,7 +5050,7 @@
       </p:sp>
       <p:sp>
         <p:nvSpPr>
-          <p:cNvPr id="47" name="TextBox 46"/>
+          <p:cNvPr id="50" name="TextBox 49"/>
           <p:cNvSpPr txBox="1"/>
           <p:nvPr/>
         </p:nvSpPr>
@@ -4976,7 +5093,7 @@
       </p:sp>
       <p:sp>
         <p:nvSpPr>
-          <p:cNvPr id="48" name="TextBox 47"/>
+          <p:cNvPr id="51" name="TextBox 50"/>
           <p:cNvSpPr txBox="1"/>
           <p:nvPr/>
         </p:nvSpPr>
@@ -5015,7 +5132,7 @@
       </p:sp>
       <p:sp>
         <p:nvSpPr>
-          <p:cNvPr id="49" name="TextBox 48"/>
+          <p:cNvPr id="52" name="TextBox 51"/>
           <p:cNvSpPr txBox="1"/>
           <p:nvPr/>
         </p:nvSpPr>
@@ -5058,7 +5175,7 @@
       </p:sp>
       <p:sp>
         <p:nvSpPr>
-          <p:cNvPr id="50" name="TextBox 49"/>
+          <p:cNvPr id="53" name="TextBox 52"/>
           <p:cNvSpPr txBox="1"/>
           <p:nvPr/>
         </p:nvSpPr>
@@ -5097,7 +5214,7 @@
       </p:sp>
       <p:sp>
         <p:nvSpPr>
-          <p:cNvPr id="51" name="TextBox 50"/>
+          <p:cNvPr id="54" name="TextBox 53"/>
           <p:cNvSpPr txBox="1"/>
           <p:nvPr/>
         </p:nvSpPr>
@@ -5140,7 +5257,7 @@
       </p:sp>
       <p:sp>
         <p:nvSpPr>
-          <p:cNvPr id="52" name="TextBox 51"/>
+          <p:cNvPr id="55" name="TextBox 54"/>
           <p:cNvSpPr txBox="1"/>
           <p:nvPr/>
         </p:nvSpPr>
@@ -5179,7 +5296,7 @@
       </p:sp>
       <p:sp>
         <p:nvSpPr>
-          <p:cNvPr id="53" name="TextBox 52"/>
+          <p:cNvPr id="56" name="TextBox 55"/>
           <p:cNvSpPr txBox="1"/>
           <p:nvPr/>
         </p:nvSpPr>
@@ -5222,7 +5339,7 @@
       </p:sp>
       <p:sp>
         <p:nvSpPr>
-          <p:cNvPr id="54" name="Rectangle 53"/>
+          <p:cNvPr id="57" name="Rectangle 56"/>
           <p:cNvSpPr/>
           <p:nvPr/>
         </p:nvSpPr>
@@ -5265,7 +5382,7 @@
       </p:sp>
       <p:sp>
         <p:nvSpPr>
-          <p:cNvPr id="55" name="TextBox 54"/>
+          <p:cNvPr id="58" name="TextBox 57"/>
           <p:cNvSpPr txBox="1"/>
           <p:nvPr/>
         </p:nvSpPr>
@@ -5304,7 +5421,7 @@
       </p:sp>
       <p:sp>
         <p:nvSpPr>
-          <p:cNvPr id="56" name="TextBox 55"/>
+          <p:cNvPr id="59" name="TextBox 58"/>
           <p:cNvSpPr txBox="1"/>
           <p:nvPr/>
         </p:nvSpPr>
@@ -5492,7 +5609,7 @@
       </p:sp>
       <p:sp>
         <p:nvSpPr>
-          <p:cNvPr id="57" name="Rectangle 56"/>
+          <p:cNvPr id="60" name="Rectangle 59"/>
           <p:cNvSpPr/>
           <p:nvPr/>
         </p:nvSpPr>
@@ -5535,7 +5652,7 @@
       </p:sp>
       <p:sp>
         <p:nvSpPr>
-          <p:cNvPr id="58" name="TextBox 57"/>
+          <p:cNvPr id="61" name="TextBox 60"/>
           <p:cNvSpPr txBox="1"/>
           <p:nvPr/>
         </p:nvSpPr>
@@ -5574,7 +5691,7 @@
       </p:sp>
       <p:sp>
         <p:nvSpPr>
-          <p:cNvPr id="59" name="TextBox 58"/>
+          <p:cNvPr id="62" name="TextBox 61"/>
           <p:cNvSpPr txBox="1"/>
           <p:nvPr/>
         </p:nvSpPr>
@@ -5606,14 +5723,14 @@
               </a:defRPr>
             </a:pPr>
             <a:r>
-              <a:t>90-Minuten-Gespräch mit einem Kundenberater Ihrer Wahl. Wir hören zu. Kein Vertrag, keine Kosten.</a:t>
-            </a:r>
-          </a:p>
-        </p:txBody>
-      </p:sp>
-      <p:sp>
-        <p:nvSpPr>
-          <p:cNvPr id="60" name="TextBox 59"/>
+              <a:t>Halbtägiger Discovery-Workshop mit Ivo und 1–2 Kundenberatern. Ergebnis: Handlungsempfehlung.</a:t>
+            </a:r>
+          </a:p>
+        </p:txBody>
+      </p:sp>
+      <p:sp>
+        <p:nvSpPr>
+          <p:cNvPr id="63" name="TextBox 62"/>
           <p:cNvSpPr txBox="1"/>
           <p:nvPr/>
         </p:nvSpPr>

</xml_diff>

<commit_message>
update: Space Grotesk, white bgs, discovery framing
Co-Authored-By: Claude Opus 4.6 (1M context) <noreply@anthropic.com>
</commit_message>
<xml_diff>
--- a/Raiffeisen-Entscheidungsvorlage.pptx
+++ b/Raiffeisen-Entscheidungsvorlage.pptx
@@ -3169,7 +3169,7 @@
                 <a:solidFill>
                   <a:srgbClr val="FFFFFF"/>
                 </a:solidFill>
-                <a:latin typeface="Arial"/>
+                <a:latin typeface="Space Grotesk"/>
               </a:defRPr>
             </a:pPr>
             <a:r>
@@ -3208,7 +3208,7 @@
                 <a:solidFill>
                   <a:srgbClr val="88AACC"/>
                 </a:solidFill>
-                <a:latin typeface="Arial"/>
+                <a:latin typeface="Space Grotesk"/>
               </a:defRPr>
             </a:pPr>
             <a:r>
@@ -3247,7 +3247,7 @@
                 <a:solidFill>
                   <a:srgbClr val="777777"/>
                 </a:solidFill>
-                <a:latin typeface="Arial"/>
+                <a:latin typeface="Space Grotesk"/>
               </a:defRPr>
             </a:pPr>
             <a:r>
@@ -3286,7 +3286,7 @@
                 <a:solidFill>
                   <a:srgbClr val="1A1A1A"/>
                 </a:solidFill>
-                <a:latin typeface="Arial"/>
+                <a:latin typeface="Space Grotesk"/>
               </a:defRPr>
             </a:pPr>
             <a:r>
@@ -3325,7 +3325,7 @@
                 <a:solidFill>
                   <a:srgbClr val="777777"/>
                 </a:solidFill>
-                <a:latin typeface="Arial"/>
+                <a:latin typeface="Space Grotesk"/>
               </a:defRPr>
             </a:pPr>
             <a:r>
@@ -3364,7 +3364,7 @@
                 <a:solidFill>
                   <a:srgbClr val="1A1A1A"/>
                 </a:solidFill>
-                <a:latin typeface="Arial"/>
+                <a:latin typeface="Space Grotesk"/>
               </a:defRPr>
             </a:pPr>
             <a:r>
@@ -3403,7 +3403,7 @@
                 <a:solidFill>
                   <a:srgbClr val="777777"/>
                 </a:solidFill>
-                <a:latin typeface="Arial"/>
+                <a:latin typeface="Space Grotesk"/>
               </a:defRPr>
             </a:pPr>
             <a:r>
@@ -3442,7 +3442,7 @@
                 <a:solidFill>
                   <a:srgbClr val="1A1A1A"/>
                 </a:solidFill>
-                <a:latin typeface="Arial"/>
+                <a:latin typeface="Space Grotesk"/>
               </a:defRPr>
             </a:pPr>
             <a:r>
@@ -3481,7 +3481,7 @@
                 <a:solidFill>
                   <a:srgbClr val="777777"/>
                 </a:solidFill>
-                <a:latin typeface="Arial"/>
+                <a:latin typeface="Space Grotesk"/>
               </a:defRPr>
             </a:pPr>
             <a:r>
@@ -3520,7 +3520,7 @@
                 <a:solidFill>
                   <a:srgbClr val="1A1A1A"/>
                 </a:solidFill>
-                <a:latin typeface="Arial"/>
+                <a:latin typeface="Space Grotesk"/>
               </a:defRPr>
             </a:pPr>
             <a:r>
@@ -3559,7 +3559,7 @@
                 <a:solidFill>
                   <a:srgbClr val="777777"/>
                 </a:solidFill>
-                <a:latin typeface="Arial"/>
+                <a:latin typeface="Space Grotesk"/>
               </a:defRPr>
             </a:pPr>
             <a:r>
@@ -3598,7 +3598,7 @@
                 <a:solidFill>
                   <a:srgbClr val="1A1A1A"/>
                 </a:solidFill>
-                <a:latin typeface="Arial"/>
+                <a:latin typeface="Space Grotesk"/>
               </a:defRPr>
             </a:pPr>
             <a:r>
@@ -3680,7 +3680,7 @@
                 <a:solidFill>
                   <a:srgbClr val="003366"/>
                 </a:solidFill>
-                <a:latin typeface="Arial"/>
+                <a:latin typeface="Space Grotesk"/>
               </a:defRPr>
             </a:pPr>
             <a:r>
@@ -3722,7 +3722,7 @@
                 <a:solidFill>
                   <a:srgbClr val="333333"/>
                 </a:solidFill>
-                <a:latin typeface="Arial"/>
+                <a:latin typeface="Space Grotesk"/>
               </a:defRPr>
             </a:pPr>
             <a:r>
@@ -3741,7 +3741,7 @@
                 <a:solidFill>
                   <a:srgbClr val="333333"/>
                 </a:solidFill>
-                <a:latin typeface="Arial"/>
+                <a:latin typeface="Space Grotesk"/>
               </a:defRPr>
             </a:pPr>
             <a:r>
@@ -3760,7 +3760,7 @@
                 <a:solidFill>
                   <a:srgbClr val="333333"/>
                 </a:solidFill>
-                <a:latin typeface="Arial"/>
+                <a:latin typeface="Space Grotesk"/>
               </a:defRPr>
             </a:pPr>
             <a:r>
@@ -3779,7 +3779,7 @@
                 <a:solidFill>
                   <a:srgbClr val="333333"/>
                 </a:solidFill>
-                <a:latin typeface="Arial"/>
+                <a:latin typeface="Space Grotesk"/>
               </a:defRPr>
             </a:pPr>
             <a:r>
@@ -3861,7 +3861,7 @@
                 <a:solidFill>
                   <a:srgbClr val="003366"/>
                 </a:solidFill>
-                <a:latin typeface="Arial"/>
+                <a:latin typeface="Space Grotesk"/>
               </a:defRPr>
             </a:pPr>
             <a:r>
@@ -3900,7 +3900,7 @@
                 <a:solidFill>
                   <a:srgbClr val="333333"/>
                 </a:solidFill>
-                <a:latin typeface="Arial"/>
+                <a:latin typeface="Space Grotesk"/>
               </a:defRPr>
             </a:pPr>
             <a:r>
@@ -3939,7 +3939,7 @@
                 <a:solidFill>
                   <a:srgbClr val="003366"/>
                 </a:solidFill>
-                <a:latin typeface="Arial"/>
+                <a:latin typeface="Space Grotesk"/>
               </a:defRPr>
             </a:pPr>
             <a:r>
@@ -3978,7 +3978,7 @@
                 <a:solidFill>
                   <a:srgbClr val="1A1A1A"/>
                 </a:solidFill>
-                <a:latin typeface="Arial"/>
+                <a:latin typeface="Space Grotesk"/>
               </a:defRPr>
             </a:pPr>
             <a:r>
@@ -4017,7 +4017,7 @@
                 <a:solidFill>
                   <a:srgbClr val="777777"/>
                 </a:solidFill>
-                <a:latin typeface="Arial"/>
+                <a:latin typeface="Space Grotesk"/>
               </a:defRPr>
             </a:pPr>
             <a:r>
@@ -4056,7 +4056,7 @@
                 <a:solidFill>
                   <a:srgbClr val="003366"/>
                 </a:solidFill>
-                <a:latin typeface="Arial"/>
+                <a:latin typeface="Space Grotesk"/>
               </a:defRPr>
             </a:pPr>
             <a:r>
@@ -4095,7 +4095,7 @@
                 <a:solidFill>
                   <a:srgbClr val="1A1A1A"/>
                 </a:solidFill>
-                <a:latin typeface="Arial"/>
+                <a:latin typeface="Space Grotesk"/>
               </a:defRPr>
             </a:pPr>
             <a:r>
@@ -4134,7 +4134,7 @@
                 <a:solidFill>
                   <a:srgbClr val="777777"/>
                 </a:solidFill>
-                <a:latin typeface="Arial"/>
+                <a:latin typeface="Space Grotesk"/>
               </a:defRPr>
             </a:pPr>
             <a:r>
@@ -4173,7 +4173,7 @@
                 <a:solidFill>
                   <a:srgbClr val="003366"/>
                 </a:solidFill>
-                <a:latin typeface="Arial"/>
+                <a:latin typeface="Space Grotesk"/>
               </a:defRPr>
             </a:pPr>
             <a:r>
@@ -4212,7 +4212,7 @@
                 <a:solidFill>
                   <a:srgbClr val="1A1A1A"/>
                 </a:solidFill>
-                <a:latin typeface="Arial"/>
+                <a:latin typeface="Space Grotesk"/>
               </a:defRPr>
             </a:pPr>
             <a:r>
@@ -4251,7 +4251,7 @@
                 <a:solidFill>
                   <a:srgbClr val="777777"/>
                 </a:solidFill>
-                <a:latin typeface="Arial"/>
+                <a:latin typeface="Space Grotesk"/>
               </a:defRPr>
             </a:pPr>
             <a:r>
@@ -4333,7 +4333,7 @@
                 <a:solidFill>
                   <a:srgbClr val="003366"/>
                 </a:solidFill>
-                <a:latin typeface="Arial"/>
+                <a:latin typeface="Space Grotesk"/>
               </a:defRPr>
             </a:pPr>
             <a:r>
@@ -4372,7 +4372,7 @@
                 <a:solidFill>
                   <a:srgbClr val="003366"/>
                 </a:solidFill>
-                <a:latin typeface="Arial"/>
+                <a:latin typeface="Space Grotesk"/>
               </a:defRPr>
             </a:pPr>
             <a:r>
@@ -4411,7 +4411,7 @@
                 <a:solidFill>
                   <a:srgbClr val="1A1A1A"/>
                 </a:solidFill>
-                <a:latin typeface="Arial"/>
+                <a:latin typeface="Space Grotesk"/>
               </a:defRPr>
             </a:pPr>
             <a:r>
@@ -4450,7 +4450,7 @@
                 <a:solidFill>
                   <a:srgbClr val="777777"/>
                 </a:solidFill>
-                <a:latin typeface="Arial"/>
+                <a:latin typeface="Space Grotesk"/>
               </a:defRPr>
             </a:pPr>
             <a:r>
@@ -4489,7 +4489,7 @@
                 <a:solidFill>
                   <a:srgbClr val="003366"/>
                 </a:solidFill>
-                <a:latin typeface="Arial"/>
+                <a:latin typeface="Space Grotesk"/>
               </a:defRPr>
             </a:pPr>
             <a:r>
@@ -4528,7 +4528,7 @@
                 <a:solidFill>
                   <a:srgbClr val="1A1A1A"/>
                 </a:solidFill>
-                <a:latin typeface="Arial"/>
+                <a:latin typeface="Space Grotesk"/>
               </a:defRPr>
             </a:pPr>
             <a:r>
@@ -4567,7 +4567,7 @@
                 <a:solidFill>
                   <a:srgbClr val="777777"/>
                 </a:solidFill>
-                <a:latin typeface="Arial"/>
+                <a:latin typeface="Space Grotesk"/>
               </a:defRPr>
             </a:pPr>
             <a:r>
@@ -4606,7 +4606,7 @@
                 <a:solidFill>
                   <a:srgbClr val="003366"/>
                 </a:solidFill>
-                <a:latin typeface="Arial"/>
+                <a:latin typeface="Space Grotesk"/>
               </a:defRPr>
             </a:pPr>
             <a:r>
@@ -4645,7 +4645,7 @@
                 <a:solidFill>
                   <a:srgbClr val="1A1A1A"/>
                 </a:solidFill>
-                <a:latin typeface="Arial"/>
+                <a:latin typeface="Space Grotesk"/>
               </a:defRPr>
             </a:pPr>
             <a:r>
@@ -4684,7 +4684,7 @@
                 <a:solidFill>
                   <a:srgbClr val="777777"/>
                 </a:solidFill>
-                <a:latin typeface="Arial"/>
+                <a:latin typeface="Space Grotesk"/>
               </a:defRPr>
             </a:pPr>
             <a:r>
@@ -4723,7 +4723,7 @@
                 <a:solidFill>
                   <a:srgbClr val="003366"/>
                 </a:solidFill>
-                <a:latin typeface="Arial"/>
+                <a:latin typeface="Space Grotesk"/>
               </a:defRPr>
             </a:pPr>
             <a:r>
@@ -4762,7 +4762,7 @@
                 <a:solidFill>
                   <a:srgbClr val="1A1A1A"/>
                 </a:solidFill>
-                <a:latin typeface="Arial"/>
+                <a:latin typeface="Space Grotesk"/>
               </a:defRPr>
             </a:pPr>
             <a:r>
@@ -4801,7 +4801,7 @@
                 <a:solidFill>
                   <a:srgbClr val="777777"/>
                 </a:solidFill>
-                <a:latin typeface="Arial"/>
+                <a:latin typeface="Space Grotesk"/>
               </a:defRPr>
             </a:pPr>
             <a:r>
@@ -4840,7 +4840,7 @@
                 <a:solidFill>
                   <a:srgbClr val="003366"/>
                 </a:solidFill>
-                <a:latin typeface="Arial"/>
+                <a:latin typeface="Space Grotesk"/>
               </a:defRPr>
             </a:pPr>
             <a:r>
@@ -4879,7 +4879,7 @@
                 <a:solidFill>
                   <a:srgbClr val="1A1A1A"/>
                 </a:solidFill>
-                <a:latin typeface="Arial"/>
+                <a:latin typeface="Space Grotesk"/>
               </a:defRPr>
             </a:pPr>
             <a:r>
@@ -4918,7 +4918,7 @@
                 <a:solidFill>
                   <a:srgbClr val="777777"/>
                 </a:solidFill>
-                <a:latin typeface="Arial"/>
+                <a:latin typeface="Space Grotesk"/>
               </a:defRPr>
             </a:pPr>
             <a:r>
@@ -5000,7 +5000,7 @@
                 <a:solidFill>
                   <a:srgbClr val="1D7A3F"/>
                 </a:solidFill>
-                <a:latin typeface="Arial"/>
+                <a:latin typeface="Space Grotesk"/>
               </a:defRPr>
             </a:pPr>
             <a:r>
@@ -5039,7 +5039,7 @@
                 <a:solidFill>
                   <a:srgbClr val="1D7A3F"/>
                 </a:solidFill>
-                <a:latin typeface="Arial"/>
+                <a:latin typeface="Space Grotesk"/>
               </a:defRPr>
             </a:pPr>
             <a:r>
@@ -5078,7 +5078,7 @@
                 <a:solidFill>
                   <a:srgbClr val="777777"/>
                 </a:solidFill>
-                <a:latin typeface="Arial"/>
+                <a:latin typeface="Space Grotesk"/>
               </a:defRPr>
             </a:pPr>
             <a:r>
@@ -5121,7 +5121,7 @@
                 <a:solidFill>
                   <a:srgbClr val="1D7A3F"/>
                 </a:solidFill>
-                <a:latin typeface="Arial"/>
+                <a:latin typeface="Space Grotesk"/>
               </a:defRPr>
             </a:pPr>
             <a:r>
@@ -5160,7 +5160,7 @@
                 <a:solidFill>
                   <a:srgbClr val="777777"/>
                 </a:solidFill>
-                <a:latin typeface="Arial"/>
+                <a:latin typeface="Space Grotesk"/>
               </a:defRPr>
             </a:pPr>
             <a:r>
@@ -5203,7 +5203,7 @@
                 <a:solidFill>
                   <a:srgbClr val="1D7A3F"/>
                 </a:solidFill>
-                <a:latin typeface="Arial"/>
+                <a:latin typeface="Space Grotesk"/>
               </a:defRPr>
             </a:pPr>
             <a:r>
@@ -5242,7 +5242,7 @@
                 <a:solidFill>
                   <a:srgbClr val="777777"/>
                 </a:solidFill>
-                <a:latin typeface="Arial"/>
+                <a:latin typeface="Space Grotesk"/>
               </a:defRPr>
             </a:pPr>
             <a:r>
@@ -5285,7 +5285,7 @@
                 <a:solidFill>
                   <a:srgbClr val="1D7A3F"/>
                 </a:solidFill>
-                <a:latin typeface="Arial"/>
+                <a:latin typeface="Space Grotesk"/>
               </a:defRPr>
             </a:pPr>
             <a:r>
@@ -5324,7 +5324,7 @@
                 <a:solidFill>
                   <a:srgbClr val="777777"/>
                 </a:solidFill>
-                <a:latin typeface="Arial"/>
+                <a:latin typeface="Space Grotesk"/>
               </a:defRPr>
             </a:pPr>
             <a:r>
@@ -5410,7 +5410,7 @@
                 <a:solidFill>
                   <a:srgbClr val="003366"/>
                 </a:solidFill>
-                <a:latin typeface="Arial"/>
+                <a:latin typeface="Space Grotesk"/>
               </a:defRPr>
             </a:pPr>
             <a:r>
@@ -5452,7 +5452,7 @@
                 <a:solidFill>
                   <a:srgbClr val="1A1A1A"/>
                 </a:solidFill>
-                <a:latin typeface="Arial"/>
+                <a:latin typeface="Space Grotesk"/>
               </a:defRPr>
             </a:pPr>
             <a:r>
@@ -5471,7 +5471,7 @@
                 <a:solidFill>
                   <a:srgbClr val="777777"/>
                 </a:solidFill>
-                <a:latin typeface="Arial"/>
+                <a:latin typeface="Space Grotesk"/>
               </a:defRPr>
             </a:pPr>
             <a:r>
@@ -5490,7 +5490,7 @@
                 <a:solidFill>
                   <a:srgbClr val="777777"/>
                 </a:solidFill>
-                <a:latin typeface="Arial"/>
+                <a:latin typeface="Space Grotesk"/>
               </a:defRPr>
             </a:pPr>
           </a:p>
@@ -5506,7 +5506,7 @@
                 <a:solidFill>
                   <a:srgbClr val="1A1A1A"/>
                 </a:solidFill>
-                <a:latin typeface="Arial"/>
+                <a:latin typeface="Space Grotesk"/>
               </a:defRPr>
             </a:pPr>
             <a:r>
@@ -5525,7 +5525,7 @@
                 <a:solidFill>
                   <a:srgbClr val="777777"/>
                 </a:solidFill>
-                <a:latin typeface="Arial"/>
+                <a:latin typeface="Space Grotesk"/>
               </a:defRPr>
             </a:pPr>
             <a:r>
@@ -5544,7 +5544,7 @@
                 <a:solidFill>
                   <a:srgbClr val="777777"/>
                 </a:solidFill>
-                <a:latin typeface="Arial"/>
+                <a:latin typeface="Space Grotesk"/>
               </a:defRPr>
             </a:pPr>
             <a:r>
@@ -5563,7 +5563,7 @@
                 <a:solidFill>
                   <a:srgbClr val="777777"/>
                 </a:solidFill>
-                <a:latin typeface="Arial"/>
+                <a:latin typeface="Space Grotesk"/>
               </a:defRPr>
             </a:pPr>
             <a:r>
@@ -5582,7 +5582,7 @@
                 <a:solidFill>
                   <a:srgbClr val="777777"/>
                 </a:solidFill>
-                <a:latin typeface="Arial"/>
+                <a:latin typeface="Space Grotesk"/>
               </a:defRPr>
             </a:pPr>
           </a:p>
@@ -5598,7 +5598,7 @@
                 <a:solidFill>
                   <a:srgbClr val="777777"/>
                 </a:solidFill>
-                <a:latin typeface="Arial"/>
+                <a:latin typeface="Space Grotesk"/>
               </a:defRPr>
             </a:pPr>
             <a:r>
@@ -5680,7 +5680,7 @@
                 <a:solidFill>
                   <a:srgbClr val="88AACC"/>
                 </a:solidFill>
-                <a:latin typeface="Arial"/>
+                <a:latin typeface="Space Grotesk"/>
               </a:defRPr>
             </a:pPr>
             <a:r>
@@ -5719,7 +5719,7 @@
                 <a:solidFill>
                   <a:srgbClr val="FFFFFF"/>
                 </a:solidFill>
-                <a:latin typeface="Arial"/>
+                <a:latin typeface="Space Grotesk"/>
               </a:defRPr>
             </a:pPr>
             <a:r>
@@ -5758,7 +5758,7 @@
                 <a:solidFill>
                   <a:srgbClr val="88AACC"/>
                 </a:solidFill>
-                <a:latin typeface="Arial"/>
+                <a:latin typeface="Space Grotesk"/>
               </a:defRPr>
             </a:pPr>
             <a:r>

</xml_diff>

<commit_message>
fix: Ausgangslage — factual, grounded
Co-Authored-By: Claude Opus 4.6 (1M context) <noreply@anthropic.com>
</commit_message>
<xml_diff>
--- a/Raiffeisen-Entscheidungsvorlage.pptx
+++ b/Raiffeisen-Entscheidungsvorlage.pptx
@@ -3726,7 +3726,7 @@
               </a:defRPr>
             </a:pPr>
             <a:r>
-              <a:t>Raiffeisen setzt bereits AI ein (Meeting-Vorbereitung, Chatbot Tina). Die Frage</a:t>
+              <a:t>AI verändert den Bankvertrieb. Raiffeisen setzt bereits erste Anwendungen ein</a:t>
             </a:r>
           </a:p>
           <a:p>
@@ -3745,7 +3745,7 @@
               </a:defRPr>
             </a:pPr>
             <a:r>
-              <a:t>ist nicht ob, sondern wo AI im Vertrieb den grössten Hebel hat. Im März 2026</a:t>
+              <a:t>(Meeting-Vorbereitung, Chatbot Tina). Die nächsten Schritte — RM-Training,</a:t>
             </a:r>
           </a:p>
           <a:p>
@@ -3764,7 +3764,7 @@
               </a:defRPr>
             </a:pPr>
             <a:r>
-              <a:t>wurde vereinbart, das gemeinsam zu erkunden — mit einem externen Partner, der</a:t>
+              <a:t>Produktwissen, Kundenansprache — sind weniger klar. Im Gespräch vom März 2026</a:t>
             </a:r>
           </a:p>
           <a:p>
@@ -3783,7 +3783,7 @@
               </a:defRPr>
             </a:pPr>
             <a:r>
-              <a:t>Produktionserfahrung mitbringt. Analog zum Vorgehen mit Allianz Suisse.</a:t>
+              <a:t>wurde angeregt, die Möglichkeiten in einem strukturierten Rahmen zu erkunden.</a:t>
             </a:r>
           </a:p>
         </p:txBody>

</xml_diff>